<commit_message>
Screenshots from the live system: README section, report appendix, deck evidence slides
Co-Authored-By: Claude Opus 5.5 <noreply@anthropic.com>
Claude-Session: https://claude.ai/code/session_01NWuP97XuxRF3YUECK7sHWt
</commit_message>
<xml_diff>
--- a/docs/Manchester.Ai_IBM_Z_Datathon_2026_Project.pptx
+++ b/docs/Manchester.Ai_IBM_Z_Datathon_2026_Project.pptx
@@ -16,9 +16,11 @@
     <p:sldId id="264" r:id="rId10"/>
     <p:sldId id="265" r:id="rId11"/>
     <p:sldId id="266" r:id="rId12"/>
+    <p:sldId id="267" r:id="rId13"/>
+    <p:sldId id="268" r:id="rId14"/>
   </p:sldIdLst>
   <p:notesMasterIdLst>
-    <p:notesMasterId r:id="rId13"/>
+    <p:notesMasterId r:id="rId15"/>
   </p:notesMasterIdLst>
   <p:sldSz cx="12192000" cy="6858000"/>
   <p:notesSz cx="6858000" cy="12192000"/>
@@ -117,39 +119,41 @@
   <p:extLst>
     <p:ext uri="{521415D9-36F7-43E2-AB2F-B90AF26B5E84}">
       <p14:sectionLst xmlns:p14="http://schemas.microsoft.com/office/powerpoint/2010/main">
-        <p14:section name="Opening" id="{4f448d36-6916-79fe-8ced-265be5537ce1}">
+        <p14:section name="Opening" id="{61c3cbfc-7af3-3508-2fc2-8b35ce6c3dc0}">
           <p14:sldIdLst>
             <p14:sldId id="256"/>
           </p14:sldIdLst>
         </p14:section>
-        <p14:section name="Problem" id="{e3300bbc-7e68-55fe-9ed1-dd753719dd89}">
+        <p14:section name="Problem" id="{61ee6f04-89ef-df24-40ef-443a47ea217a}">
           <p14:sldIdLst>
             <p14:sldId id="257"/>
           </p14:sldIdLst>
         </p14:section>
-        <p14:section name="Data and model" id="{dc46a4c6-7025-319c-5aa7-f213910f684c}">
+        <p14:section name="Data and model" id="{044602b8-68e6-7713-7d0e-1fccf9de81e0}">
           <p14:sldIdLst>
             <p14:sldId id="258"/>
             <p14:sldId id="259"/>
             <p14:sldId id="260"/>
           </p14:sldIdLst>
         </p14:section>
-        <p14:section name="Results" id="{b77718be-db06-6b8d-1298-03219777a446}">
+        <p14:section name="Results" id="{26ea2fa7-a914-cae3-2b7f-298def47b179}">
           <p14:sldIdLst>
             <p14:sldId id="261"/>
             <p14:sldId id="262"/>
           </p14:sldIdLst>
         </p14:section>
-        <p14:section name="Demo and platform" id="{330bae5f-28fe-012d-76a7-7498f17e74b8}">
+        <p14:section name="Demo and platform" id="{9937c0df-ec42-be94-38de-fff37d4483e2}">
           <p14:sldIdLst>
             <p14:sldId id="263"/>
             <p14:sldId id="264"/>
+            <p14:sldId id="265"/>
+            <p14:sldId id="266"/>
           </p14:sldIdLst>
         </p14:section>
-        <p14:section name="Close" id="{c4f101c3-6c27-0093-20af-485de4713bc6}">
+        <p14:section name="Close" id="{c3d1d42c-51d9-67c4-2499-d5b475a2bdb4}">
           <p14:sldIdLst>
-            <p14:sldId id="265"/>
-            <p14:sldId id="266"/>
+            <p14:sldId id="267"/>
+            <p14:sldId id="268"/>
           </p14:sldIdLst>
         </p14:section>
       </p14:sectionLst>
@@ -994,7 +998,7 @@
           <a:p>
             <a:r>
               <a:rPr lang="en-US" dirty="0"/>
-              <a:t>Responsible design: the student is never told they are suspected, a person makes every serious decision, and the model uses only how money moves. Limitations: synthetic data, so real-world accuracy needs real bank data.</a:t>
+              <a:t>Everything runs on LinuxONE: data loading, features, training in 19 seconds with no GPU, and live scoring in under a millisecond. Two Docker containers on IBM's s390x base image; the model service is on a private network and only the web app is public. Show the s390x badge and /health here.</a:t>
             </a:r>
             <a:endParaRPr lang="en-US" dirty="0"/>
           </a:p>
@@ -1082,7 +1086,7 @@
           <a:p>
             <a:r>
               <a:rPr lang="en-US" dirty="0"/>
-              <a:t>StudentShield is a smoke alarm, not a fire investigation: it goes off while there is still time. Thank you.</a:t>
+              <a:t>Evidence for the platform: the VM on LinuxONE Community Cloud, the live health endpoint reporting s390x, training on s390x in 19 seconds, and the full replay scoring at 0.55 ms per payment.</a:t>
             </a:r>
             <a:endParaRPr lang="en-US" dirty="0"/>
           </a:p>
@@ -1106,6 +1110,182 @@
             <a:fld id="{F7021451-1387-4CA6-816F-3879F97B5CBC}" type="slidenum">
               <a:rPr lang="en-US"/>
               <a:t>11</a:t>
+            </a:fld>
+            <a:endParaRPr lang="en-US"/>
+          </a:p>
+        </p:txBody>
+      </p:sp>
+    </p:spTree>
+    <p:extLst>
+      <p:ext uri="{BB962C8B-B14F-4D97-AF65-F5344CB8AC3E}">
+        <p14:creationId xmlns:p14="http://schemas.microsoft.com/office/powerpoint/2010/main" val="1024086991"/>
+      </p:ext>
+    </p:extLst>
+  </p:cSld>
+  <p:clrMapOvr>
+    <a:masterClrMapping/>
+  </p:clrMapOvr>
+</p:notes>
+</file>
+
+<file path=ppt/notesSlides/notesSlide12.xml><?xml version="1.0" encoding="utf-8"?>
+<p:notes xmlns:a="http://schemas.openxmlformats.org/drawingml/2006/main" xmlns:r="http://schemas.openxmlformats.org/officeDocument/2006/relationships" xmlns:p="http://schemas.openxmlformats.org/presentationml/2006/main">
+  <p:cSld>
+    <p:spTree>
+      <p:nvGrpSpPr>
+        <p:cNvPr id="1" name=""/>
+        <p:cNvGrpSpPr/>
+        <p:nvPr/>
+      </p:nvGrpSpPr>
+      <p:grpSpPr>
+        <a:xfrm>
+          <a:off x="0" y="0"/>
+          <a:ext cx="0" cy="0"/>
+          <a:chOff x="0" y="0"/>
+          <a:chExt cx="0" cy="0"/>
+        </a:xfrm>
+      </p:grpSpPr>
+      <p:sp>
+        <p:nvSpPr>
+          <p:cNvPr id="2" name="Slide Image Placeholder 1"/>
+          <p:cNvSpPr>
+            <a:spLocks noGrp="1" noRot="1" noChangeAspect="1"/>
+          </p:cNvSpPr>
+          <p:nvPr>
+            <p:ph type="sldImg"/>
+          </p:nvPr>
+        </p:nvSpPr>
+        <p:spPr/>
+      </p:sp>
+      <p:sp>
+        <p:nvSpPr>
+          <p:cNvPr id="3" name="Notes Placeholder 2"/>
+          <p:cNvSpPr>
+            <a:spLocks noGrp="1"/>
+          </p:cNvSpPr>
+          <p:nvPr>
+            <p:ph type="body" idx="1"/>
+          </p:nvPr>
+        </p:nvSpPr>
+        <p:spPr/>
+        <p:txBody>
+          <a:bodyPr/>
+          <a:lstStyle/>
+          <a:p>
+            <a:r>
+              <a:rPr lang="en-US" dirty="0"/>
+              <a:t>Responsible design: the student is never told they are suspected, a person makes every serious decision, and the model uses only how money moves. Limitations: synthetic data, so real-world accuracy needs real bank data.</a:t>
+            </a:r>
+            <a:endParaRPr lang="en-US" dirty="0"/>
+          </a:p>
+        </p:txBody>
+      </p:sp>
+      <p:sp>
+        <p:nvSpPr>
+          <p:cNvPr id="4" name="Slide Number Placeholder 3"/>
+          <p:cNvSpPr>
+            <a:spLocks noGrp="1"/>
+          </p:cNvSpPr>
+          <p:nvPr>
+            <p:ph type="sldNum" sz="quarter" idx="10"/>
+          </p:nvPr>
+        </p:nvSpPr>
+        <p:spPr/>
+        <p:txBody>
+          <a:bodyPr/>
+          <a:lstStyle/>
+          <a:p>
+            <a:fld id="{F7021451-1387-4CA6-816F-3879F97B5CBC}" type="slidenum">
+              <a:rPr lang="en-US"/>
+              <a:t>12</a:t>
+            </a:fld>
+            <a:endParaRPr lang="en-US"/>
+          </a:p>
+        </p:txBody>
+      </p:sp>
+    </p:spTree>
+    <p:extLst>
+      <p:ext uri="{BB962C8B-B14F-4D97-AF65-F5344CB8AC3E}">
+        <p14:creationId xmlns:p14="http://schemas.microsoft.com/office/powerpoint/2010/main" val="1024086991"/>
+      </p:ext>
+    </p:extLst>
+  </p:cSld>
+  <p:clrMapOvr>
+    <a:masterClrMapping/>
+  </p:clrMapOvr>
+</p:notes>
+</file>
+
+<file path=ppt/notesSlides/notesSlide13.xml><?xml version="1.0" encoding="utf-8"?>
+<p:notes xmlns:a="http://schemas.openxmlformats.org/drawingml/2006/main" xmlns:r="http://schemas.openxmlformats.org/officeDocument/2006/relationships" xmlns:p="http://schemas.openxmlformats.org/presentationml/2006/main">
+  <p:cSld>
+    <p:spTree>
+      <p:nvGrpSpPr>
+        <p:cNvPr id="1" name=""/>
+        <p:cNvGrpSpPr/>
+        <p:nvPr/>
+      </p:nvGrpSpPr>
+      <p:grpSpPr>
+        <a:xfrm>
+          <a:off x="0" y="0"/>
+          <a:ext cx="0" cy="0"/>
+          <a:chOff x="0" y="0"/>
+          <a:chExt cx="0" cy="0"/>
+        </a:xfrm>
+      </p:grpSpPr>
+      <p:sp>
+        <p:nvSpPr>
+          <p:cNvPr id="2" name="Slide Image Placeholder 1"/>
+          <p:cNvSpPr>
+            <a:spLocks noGrp="1" noRot="1" noChangeAspect="1"/>
+          </p:cNvSpPr>
+          <p:nvPr>
+            <p:ph type="sldImg"/>
+          </p:nvPr>
+        </p:nvSpPr>
+        <p:spPr/>
+      </p:sp>
+      <p:sp>
+        <p:nvSpPr>
+          <p:cNvPr id="3" name="Notes Placeholder 2"/>
+          <p:cNvSpPr>
+            <a:spLocks noGrp="1"/>
+          </p:cNvSpPr>
+          <p:nvPr>
+            <p:ph type="body" idx="1"/>
+          </p:nvPr>
+        </p:nvSpPr>
+        <p:spPr/>
+        <p:txBody>
+          <a:bodyPr/>
+          <a:lstStyle/>
+          <a:p>
+            <a:r>
+              <a:rPr lang="en-US" dirty="0"/>
+              <a:t>StudentShield is a smoke alarm, not a fire investigation: it goes off while there is still time. Thank you.</a:t>
+            </a:r>
+            <a:endParaRPr lang="en-US" dirty="0"/>
+          </a:p>
+        </p:txBody>
+      </p:sp>
+      <p:sp>
+        <p:nvSpPr>
+          <p:cNvPr id="4" name="Slide Number Placeholder 3"/>
+          <p:cNvSpPr>
+            <a:spLocks noGrp="1"/>
+          </p:cNvSpPr>
+          <p:nvPr>
+            <p:ph type="sldNum" sz="quarter" idx="10"/>
+          </p:nvPr>
+        </p:nvSpPr>
+        <p:spPr/>
+        <p:txBody>
+          <a:bodyPr/>
+          <a:lstStyle/>
+          <a:p>
+            <a:fld id="{F7021451-1387-4CA6-816F-3879F97B5CBC}" type="slidenum">
+              <a:rPr lang="en-US"/>
+              <a:t>13</a:t>
             </a:fld>
             <a:endParaRPr lang="en-US"/>
           </a:p>
@@ -1786,7 +1966,7 @@
           <a:p>
             <a:r>
               <a:rPr lang="en-US" dirty="0"/>
-              <a:t>Everything runs on LinuxONE: data loading, features, training in 19 seconds with no GPU, and live scoring in under a millisecond. Two Docker containers on IBM's s390x base image; the model service is on a private network and only the web app is public. Show the s390x badge and /health here.</a:t>
+              <a:t>Real test-day case: the student was warned 19 hours 17 minutes before the money moved out, and the outbound transfer was held. Badge top left: Running on IBM LinuxONE, s390x.</a:t>
             </a:r>
             <a:endParaRPr lang="en-US" dirty="0"/>
           </a:p>
@@ -2702,7 +2882,7 @@
                   <a:schemeClr val="tx1"/>
                 </a:solidFill>
               </a:rPr>
-              <a:t>Designed to protect students, not accuse them</a:t>
+              <a:t>Built and running end to end on IBM LinuxONE (s390x)</a:t>
             </a:r>
             <a:endParaRPr lang="en-US" sz="3200" dirty="0"/>
           </a:p>
@@ -2710,18 +2890,18 @@
       </p:sp>
       <p:sp>
         <p:nvSpPr>
-          <p:cNvPr id="3" name="ethics 1"/>
+          <p:cNvPr id="3" name="vm box"/>
           <p:cNvSpPr/>
           <p:nvPr/>
         </p:nvSpPr>
         <p:spPr>
           <a:xfrm>
-            <a:off x="548640" y="1463040"/>
-            <a:ext cx="5440680" cy="1417320"/>
+            <a:off x="548640" y="1371600"/>
+            <a:ext cx="6949440" cy="4754880"/>
           </a:xfrm>
           <a:prstGeom prst="roundRect">
             <a:avLst>
-              <a:gd name="adj" fmla="val 7742"/>
+              <a:gd name="adj" fmla="val 2308"/>
             </a:avLst>
           </a:prstGeom>
           <a:solidFill>
@@ -2729,7 +2909,70 @@
           </a:solidFill>
           <a:ln w="12700">
             <a:solidFill>
-              <a:srgbClr val="F2F4F8"/>
+              <a:srgbClr val="8D8D8D"/>
+            </a:solidFill>
+            <a:prstDash val="dash"/>
+          </a:ln>
+        </p:spPr>
+      </p:sp>
+      <p:sp>
+        <p:nvSpPr>
+          <p:cNvPr id="4" name="Text 2"/>
+          <p:cNvSpPr txBox="1"/>
+          <p:nvPr/>
+        </p:nvSpPr>
+        <p:spPr>
+          <a:xfrm>
+            <a:off x="822960" y="1463040"/>
+            <a:ext cx="6492240" cy="365760"/>
+          </a:xfrm>
+          <a:prstGeom prst="rect">
+            <a:avLst/>
+          </a:prstGeom>
+          <a:noFill/>
+          <a:ln/>
+        </p:spPr>
+        <p:txBody>
+          <a:bodyPr wrap="square" lIns="0" tIns="0" rIns="0" bIns="0" rtlCol="0" anchor="ctr"/>
+          <a:lstStyle/>
+          <a:p>
+            <a:pPr indent="0" marL="0">
+              <a:buNone/>
+            </a:pPr>
+            <a:r>
+              <a:rPr lang="en-US" sz="1300" b="1" dirty="0">
+                <a:solidFill>
+                  <a:srgbClr val="525252"/>
+                </a:solidFill>
+              </a:rPr>
+              <a:t>LinuxONE Community Cloud VM · s390x · 3 vCPU, 8 GB, no GPU</a:t>
+            </a:r>
+            <a:endParaRPr lang="en-US" sz="1300" dirty="0"/>
+          </a:p>
+        </p:txBody>
+      </p:sp>
+      <p:sp>
+        <p:nvSpPr>
+          <p:cNvPr id="5" name="jupyter"/>
+          <p:cNvSpPr/>
+          <p:nvPr/>
+        </p:nvSpPr>
+        <p:spPr>
+          <a:xfrm>
+            <a:off x="822960" y="1965960"/>
+            <a:ext cx="3017520" cy="1371600"/>
+          </a:xfrm>
+          <a:prstGeom prst="roundRect">
+            <a:avLst>
+              <a:gd name="adj" fmla="val 8000"/>
+            </a:avLst>
+          </a:prstGeom>
+          <a:solidFill>
+            <a:srgbClr val="FFFFFF"/>
+          </a:solidFill>
+          <a:ln w="12700">
+            <a:solidFill>
+              <a:srgbClr val="FFFFFF"/>
             </a:solidFill>
             <a:prstDash val="solid"/>
           </a:ln>
@@ -2737,24 +2980,76 @@
       </p:sp>
       <p:sp>
         <p:nvSpPr>
-          <p:cNvPr id="4" name="tick 1"/>
+          <p:cNvPr id="6" name="Text 4"/>
+          <p:cNvSpPr txBox="1"/>
+          <p:nvPr/>
+        </p:nvSpPr>
+        <p:spPr>
+          <a:xfrm>
+            <a:off x="1005840" y="2057400"/>
+            <a:ext cx="2651760" cy="1188720"/>
+          </a:xfrm>
+          <a:prstGeom prst="rect">
+            <a:avLst/>
+          </a:prstGeom>
+          <a:noFill/>
+          <a:ln/>
+        </p:spPr>
+        <p:txBody>
+          <a:bodyPr wrap="square" lIns="0" tIns="0" rIns="0" bIns="0" rtlCol="0" anchor="t"/>
+          <a:lstStyle/>
+          <a:p>
+            <a:pPr indent="0" marL="0">
+              <a:buNone/>
+            </a:pPr>
+            <a:r>
+              <a:rPr lang="en-US" sz="1600" b="1" dirty="0">
+                <a:solidFill>
+                  <a:srgbClr val="161616"/>
+                </a:solidFill>
+              </a:rPr>
+              <a:t>Jupyter container</a:t>
+            </a:r>
+            <a:endParaRPr lang="en-US" sz="1600" dirty="0"/>
+          </a:p>
+          <a:p>
+            <a:pPr indent="0" marL="0">
+              <a:buNone/>
+            </a:pPr>
+            <a:r>
+              <a:rPr lang="en-US" sz="1200" dirty="0">
+                <a:solidFill>
+                  <a:srgbClr val="161616"/>
+                </a:solidFill>
+              </a:rPr>
+              <a:t>Notebooks 01–03: cleaning, 25 features, XGBoost trained in 19.0 s</a:t>
+            </a:r>
+            <a:endParaRPr lang="en-US" sz="1600" dirty="0"/>
+          </a:p>
+        </p:txBody>
+      </p:sp>
+      <p:sp>
+        <p:nvSpPr>
+          <p:cNvPr id="7" name="mule-service"/>
           <p:cNvSpPr/>
           <p:nvPr/>
         </p:nvSpPr>
         <p:spPr>
           <a:xfrm>
-            <a:off x="777240" y="1737360"/>
-            <a:ext cx="411480" cy="411480"/>
-          </a:xfrm>
-          <a:prstGeom prst="ellipse">
-            <a:avLst/>
+            <a:off x="822960" y="4114800"/>
+            <a:ext cx="3017520" cy="1737360"/>
+          </a:xfrm>
+          <a:prstGeom prst="roundRect">
+            <a:avLst>
+              <a:gd name="adj" fmla="val 6316"/>
+            </a:avLst>
           </a:prstGeom>
           <a:solidFill>
-            <a:schemeClr val="accent4"/>
+            <a:srgbClr val="0F62FE"/>
           </a:solidFill>
           <a:ln w="12700">
             <a:solidFill>
-              <a:schemeClr val="accent4"/>
+              <a:srgbClr val="0F62FE"/>
             </a:solidFill>
             <a:prstDash val="solid"/>
           </a:ln>
@@ -2762,112 +3057,76 @@
       </p:sp>
       <p:sp>
         <p:nvSpPr>
-          <p:cNvPr id="5" name="Text 3"/>
-          <p:cNvSpPr txBox="1"/>
-          <p:nvPr/>
-        </p:nvSpPr>
-        <p:spPr>
-          <a:xfrm>
-            <a:off x="777240" y="1737360"/>
-            <a:ext cx="411480" cy="411480"/>
-          </a:xfrm>
-          <a:prstGeom prst="rect">
-            <a:avLst/>
-          </a:prstGeom>
-          <a:noFill/>
-          <a:ln/>
-        </p:spPr>
-        <p:txBody>
-          <a:bodyPr wrap="square" lIns="0" tIns="0" rIns="0" bIns="0" rtlCol="0" anchor="ctr"/>
-          <a:lstStyle/>
-          <a:p>
-            <a:pPr algn="ctr" indent="0" marL="0">
+          <p:cNvPr id="8" name="Text 6"/>
+          <p:cNvSpPr txBox="1"/>
+          <p:nvPr/>
+        </p:nvSpPr>
+        <p:spPr>
+          <a:xfrm>
+            <a:off x="1005840" y="4206240"/>
+            <a:ext cx="2651760" cy="1554480"/>
+          </a:xfrm>
+          <a:prstGeom prst="rect">
+            <a:avLst/>
+          </a:prstGeom>
+          <a:noFill/>
+          <a:ln/>
+        </p:spPr>
+        <p:txBody>
+          <a:bodyPr wrap="square" lIns="0" tIns="0" rIns="0" bIns="0" rtlCol="0" anchor="t"/>
+          <a:lstStyle/>
+          <a:p>
+            <a:pPr indent="0" marL="0">
               <a:buNone/>
             </a:pPr>
             <a:r>
               <a:rPr lang="en-US" sz="1600" b="1" dirty="0">
                 <a:solidFill>
-                  <a:schemeClr val="bg1"/>
-                </a:solidFill>
-              </a:rPr>
-              <a:t>✓</a:t>
+                  <a:srgbClr val="FFFFFF"/>
+                </a:solidFill>
+              </a:rPr>
+              <a:t>mule-service</a:t>
             </a:r>
             <a:endParaRPr lang="en-US" sz="1600" dirty="0"/>
           </a:p>
-        </p:txBody>
-      </p:sp>
-      <p:sp>
-        <p:nvSpPr>
-          <p:cNvPr id="6" name="Text 4"/>
-          <p:cNvSpPr txBox="1"/>
-          <p:nvPr/>
-        </p:nvSpPr>
-        <p:spPr>
-          <a:xfrm>
-            <a:off x="1371600" y="1645920"/>
-            <a:ext cx="4434840" cy="1097280"/>
-          </a:xfrm>
-          <a:prstGeom prst="rect">
-            <a:avLst/>
-          </a:prstGeom>
-          <a:noFill/>
-          <a:ln/>
-        </p:spPr>
-        <p:txBody>
-          <a:bodyPr wrap="square" lIns="0" tIns="0" rIns="0" bIns="0" rtlCol="0" anchor="t"/>
-          <a:lstStyle/>
-          <a:p>
-            <a:pPr indent="0" marL="0">
-              <a:buNone/>
-            </a:pPr>
-            <a:r>
-              <a:rPr lang="en-US" sz="1400" b="1" dirty="0">
-                <a:solidFill>
-                  <a:schemeClr val="tx1"/>
-                </a:solidFill>
-              </a:rPr>
-              <a:t>No tipping off</a:t>
-            </a:r>
-            <a:endParaRPr lang="en-US" sz="1400" dirty="0"/>
-          </a:p>
-          <a:p>
-            <a:pPr indent="0" marL="0">
-              <a:buNone/>
-            </a:pPr>
-            <a:r>
-              <a:rPr lang="en-US" sz="1400" dirty="0">
-                <a:solidFill>
-                  <a:srgbClr val="525252"/>
-                </a:solidFill>
-              </a:rPr>
-              <a:t>The phone never shows a score, reason or suspicion: only a safeguarding question banks already ask</a:t>
-            </a:r>
-            <a:endParaRPr lang="en-US" sz="1400" dirty="0"/>
-          </a:p>
-        </p:txBody>
-      </p:sp>
-      <p:sp>
-        <p:nvSpPr>
-          <p:cNvPr id="7" name="ethics 2"/>
+          <a:p>
+            <a:pPr indent="0" marL="0">
+              <a:buNone/>
+            </a:pPr>
+            <a:r>
+              <a:rPr lang="en-US" sz="1200" dirty="0">
+                <a:solidFill>
+                  <a:srgbClr val="FFFFFF"/>
+                </a:solidFill>
+              </a:rPr>
+              <a:t>Flask + XGBoost scoring API. Private network only, no public port</a:t>
+            </a:r>
+            <a:endParaRPr lang="en-US" sz="1600" dirty="0"/>
+          </a:p>
+        </p:txBody>
+      </p:sp>
+      <p:sp>
+        <p:nvSpPr>
+          <p:cNvPr id="9" name="studentshield"/>
           <p:cNvSpPr/>
           <p:nvPr/>
         </p:nvSpPr>
         <p:spPr>
           <a:xfrm>
-            <a:off x="6172200" y="1463040"/>
-            <a:ext cx="5440680" cy="1417320"/>
+            <a:off x="4251960" y="4114800"/>
+            <a:ext cx="3017520" cy="1737360"/>
           </a:xfrm>
           <a:prstGeom prst="roundRect">
             <a:avLst>
-              <a:gd name="adj" fmla="val 7742"/>
+              <a:gd name="adj" fmla="val 6316"/>
             </a:avLst>
           </a:prstGeom>
           <a:solidFill>
-            <a:srgbClr val="F2F4F8"/>
+            <a:srgbClr val="0F2B5B"/>
           </a:solidFill>
           <a:ln w="12700">
             <a:solidFill>
-              <a:srgbClr val="F2F4F8"/>
+              <a:srgbClr val="0F2B5B"/>
             </a:solidFill>
             <a:prstDash val="solid"/>
           </a:ln>
@@ -2875,39 +3134,64 @@
       </p:sp>
       <p:sp>
         <p:nvSpPr>
-          <p:cNvPr id="8" name="tick 2"/>
-          <p:cNvSpPr/>
-          <p:nvPr/>
-        </p:nvSpPr>
-        <p:spPr>
-          <a:xfrm>
-            <a:off x="6400800" y="1737360"/>
-            <a:ext cx="411480" cy="411480"/>
-          </a:xfrm>
-          <a:prstGeom prst="ellipse">
-            <a:avLst/>
-          </a:prstGeom>
-          <a:solidFill>
-            <a:schemeClr val="accent4"/>
-          </a:solidFill>
-          <a:ln w="12700">
-            <a:solidFill>
-              <a:schemeClr val="accent4"/>
-            </a:solidFill>
-            <a:prstDash val="solid"/>
-          </a:ln>
-        </p:spPr>
-      </p:sp>
-      <p:sp>
-        <p:nvSpPr>
-          <p:cNvPr id="9" name="Text 7"/>
-          <p:cNvSpPr txBox="1"/>
-          <p:nvPr/>
-        </p:nvSpPr>
-        <p:spPr>
-          <a:xfrm>
-            <a:off x="6400800" y="1737360"/>
-            <a:ext cx="411480" cy="411480"/>
+          <p:cNvPr id="10" name="Text 8"/>
+          <p:cNvSpPr txBox="1"/>
+          <p:nvPr/>
+        </p:nvSpPr>
+        <p:spPr>
+          <a:xfrm>
+            <a:off x="4434840" y="4206240"/>
+            <a:ext cx="2651760" cy="1554480"/>
+          </a:xfrm>
+          <a:prstGeom prst="rect">
+            <a:avLst/>
+          </a:prstGeom>
+          <a:noFill/>
+          <a:ln/>
+        </p:spPr>
+        <p:txBody>
+          <a:bodyPr wrap="square" lIns="0" tIns="0" rIns="0" bIns="0" rtlCol="0" anchor="t"/>
+          <a:lstStyle/>
+          <a:p>
+            <a:pPr indent="0" marL="0">
+              <a:buNone/>
+            </a:pPr>
+            <a:r>
+              <a:rPr lang="en-US" sz="1600" b="1" dirty="0">
+                <a:solidFill>
+                  <a:srgbClr val="FFFFFF"/>
+                </a:solidFill>
+              </a:rPr>
+              <a:t>studentshield</a:t>
+            </a:r>
+            <a:endParaRPr lang="en-US" sz="1600" dirty="0"/>
+          </a:p>
+          <a:p>
+            <a:pPr indent="0" marL="0">
+              <a:buNone/>
+            </a:pPr>
+            <a:r>
+              <a:rPr lang="en-US" sz="1200" dirty="0">
+                <a:solidFill>
+                  <a:srgbClr val="FFFFFF"/>
+                </a:solidFill>
+              </a:rPr>
+              <a:t>Flask web app, the only public port (5000)</a:t>
+            </a:r>
+            <a:endParaRPr lang="en-US" sz="1600" dirty="0"/>
+          </a:p>
+        </p:txBody>
+      </p:sp>
+      <p:sp>
+        <p:nvSpPr>
+          <p:cNvPr id="11" name="Text 9"/>
+          <p:cNvSpPr txBox="1"/>
+          <p:nvPr/>
+        </p:nvSpPr>
+        <p:spPr>
+          <a:xfrm>
+            <a:off x="822960" y="3520440"/>
+            <a:ext cx="3017520" cy="411480"/>
           </a:xfrm>
           <a:prstGeom prst="rect">
             <a:avLst/>
@@ -2923,27 +3207,77 @@
               <a:buNone/>
             </a:pPr>
             <a:r>
-              <a:rPr lang="en-US" sz="1600" b="1" dirty="0">
-                <a:solidFill>
-                  <a:schemeClr val="bg1"/>
-                </a:solidFill>
-              </a:rPr>
-              <a:t>✓</a:t>
-            </a:r>
-            <a:endParaRPr lang="en-US" sz="1600" dirty="0"/>
-          </a:p>
-        </p:txBody>
-      </p:sp>
-      <p:sp>
-        <p:nvSpPr>
-          <p:cNvPr id="10" name="Text 8"/>
-          <p:cNvSpPr txBox="1"/>
-          <p:nvPr/>
-        </p:nvSpPr>
-        <p:spPr>
-          <a:xfrm>
-            <a:off x="6995160" y="1645920"/>
-            <a:ext cx="4434840" cy="1097280"/>
+              <a:rPr lang="en-US" sz="1100" dirty="0">
+                <a:solidFill>
+                  <a:srgbClr val="525252"/>
+                </a:solidFill>
+              </a:rPr>
+              <a:t>model + cut-offs</a:t>
+            </a:r>
+            <a:endParaRPr lang="en-US" sz="1100" dirty="0"/>
+          </a:p>
+          <a:p>
+            <a:pPr algn="ctr" indent="0" marL="0">
+              <a:buNone/>
+            </a:pPr>
+            <a:r>
+              <a:rPr lang="en-US" sz="1100" dirty="0">
+                <a:solidFill>
+                  <a:srgbClr val="525252"/>
+                </a:solidFill>
+              </a:rPr>
+              <a:t>(shared folder) ↓</a:t>
+            </a:r>
+            <a:endParaRPr lang="en-US" sz="1100" dirty="0"/>
+          </a:p>
+        </p:txBody>
+      </p:sp>
+      <p:sp>
+        <p:nvSpPr>
+          <p:cNvPr id="12" name="Text 10"/>
+          <p:cNvSpPr txBox="1"/>
+          <p:nvPr/>
+        </p:nvSpPr>
+        <p:spPr>
+          <a:xfrm>
+            <a:off x="3840480" y="3749040"/>
+            <a:ext cx="914400" cy="320040"/>
+          </a:xfrm>
+          <a:prstGeom prst="rect">
+            <a:avLst/>
+          </a:prstGeom>
+          <a:noFill/>
+          <a:ln/>
+        </p:spPr>
+        <p:txBody>
+          <a:bodyPr wrap="square" lIns="0" tIns="0" rIns="0" bIns="0" rtlCol="0" anchor="ctr"/>
+          <a:lstStyle/>
+          <a:p>
+            <a:pPr algn="ctr" indent="0" marL="0">
+              <a:buNone/>
+            </a:pPr>
+            <a:r>
+              <a:rPr lang="en-US" sz="1000" dirty="0">
+                <a:solidFill>
+                  <a:srgbClr val="525252"/>
+                </a:solidFill>
+              </a:rPr>
+              <a:t>mule-net ↔</a:t>
+            </a:r>
+            <a:endParaRPr lang="en-US" sz="1000" dirty="0"/>
+          </a:p>
+        </p:txBody>
+      </p:sp>
+      <p:sp>
+        <p:nvSpPr>
+          <p:cNvPr id="13" name="Text 11"/>
+          <p:cNvSpPr txBox="1"/>
+          <p:nvPr/>
+        </p:nvSpPr>
+        <p:spPr>
+          <a:xfrm>
+            <a:off x="7863840" y="1417320"/>
+            <a:ext cx="3749040" cy="1097280"/>
           </a:xfrm>
           <a:prstGeom prst="rect">
             <a:avLst/>
@@ -2961,10 +3295,10 @@
             <a:r>
               <a:rPr lang="en-US" sz="1400" b="1" dirty="0">
                 <a:solidFill>
-                  <a:schemeClr val="tx1"/>
-                </a:solidFill>
-              </a:rPr>
-              <a:t>A person decides</a:t>
+                  <a:srgbClr val="0F62FE"/>
+                </a:solidFill>
+              </a:rPr>
+              <a:t>On-platform AI</a:t>
             </a:r>
             <a:endParaRPr lang="en-US" sz="1400" dirty="0"/>
           </a:p>
@@ -2975,10 +3309,10 @@
             <a:r>
               <a:rPr lang="en-US" sz="1400" dirty="0">
                 <a:solidFill>
-                  <a:srgbClr val="525252"/>
-                </a:solidFill>
-              </a:rPr>
-              <a:t>The model never freezes an account or files a report; an analyst reviews every alert</a:t>
+                  <a:srgbClr val="161616"/>
+                </a:solidFill>
+              </a:rPr>
+              <a:t>Training and scoring both run on s390x; payment data never leaves the platform it lives on</a:t>
             </a:r>
             <a:endParaRPr lang="en-US" sz="1400" dirty="0"/>
           </a:p>
@@ -2986,102 +3320,14 @@
       </p:sp>
       <p:sp>
         <p:nvSpPr>
-          <p:cNvPr id="11" name="ethics 3"/>
-          <p:cNvSpPr/>
-          <p:nvPr/>
-        </p:nvSpPr>
-        <p:spPr>
-          <a:xfrm>
-            <a:off x="548640" y="3063240"/>
-            <a:ext cx="5440680" cy="1417320"/>
-          </a:xfrm>
-          <a:prstGeom prst="roundRect">
-            <a:avLst>
-              <a:gd name="adj" fmla="val 7742"/>
-            </a:avLst>
-          </a:prstGeom>
-          <a:solidFill>
-            <a:srgbClr val="F2F4F8"/>
-          </a:solidFill>
-          <a:ln w="12700">
-            <a:solidFill>
-              <a:srgbClr val="F2F4F8"/>
-            </a:solidFill>
-            <a:prstDash val="solid"/>
-          </a:ln>
-        </p:spPr>
-      </p:sp>
-      <p:sp>
-        <p:nvSpPr>
-          <p:cNvPr id="12" name="tick 3"/>
-          <p:cNvSpPr/>
-          <p:nvPr/>
-        </p:nvSpPr>
-        <p:spPr>
-          <a:xfrm>
-            <a:off x="777240" y="3337560"/>
-            <a:ext cx="411480" cy="411480"/>
-          </a:xfrm>
-          <a:prstGeom prst="ellipse">
-            <a:avLst/>
-          </a:prstGeom>
-          <a:solidFill>
-            <a:schemeClr val="accent4"/>
-          </a:solidFill>
-          <a:ln w="12700">
-            <a:solidFill>
-              <a:schemeClr val="accent4"/>
-            </a:solidFill>
-            <a:prstDash val="solid"/>
-          </a:ln>
-        </p:spPr>
-      </p:sp>
-      <p:sp>
-        <p:nvSpPr>
-          <p:cNvPr id="13" name="Text 11"/>
-          <p:cNvSpPr txBox="1"/>
-          <p:nvPr/>
-        </p:nvSpPr>
-        <p:spPr>
-          <a:xfrm>
-            <a:off x="777240" y="3337560"/>
-            <a:ext cx="411480" cy="411480"/>
-          </a:xfrm>
-          <a:prstGeom prst="rect">
-            <a:avLst/>
-          </a:prstGeom>
-          <a:noFill/>
-          <a:ln/>
-        </p:spPr>
-        <p:txBody>
-          <a:bodyPr wrap="square" lIns="0" tIns="0" rIns="0" bIns="0" rtlCol="0" anchor="ctr"/>
-          <a:lstStyle/>
-          <a:p>
-            <a:pPr algn="ctr" indent="0" marL="0">
-              <a:buNone/>
-            </a:pPr>
-            <a:r>
-              <a:rPr lang="en-US" sz="1600" b="1" dirty="0">
-                <a:solidFill>
-                  <a:schemeClr val="bg1"/>
-                </a:solidFill>
-              </a:rPr>
-              <a:t>✓</a:t>
-            </a:r>
-            <a:endParaRPr lang="en-US" sz="1600" dirty="0"/>
-          </a:p>
-        </p:txBody>
-      </p:sp>
-      <p:sp>
-        <p:nvSpPr>
           <p:cNvPr id="14" name="Text 12"/>
           <p:cNvSpPr txBox="1"/>
           <p:nvPr/>
         </p:nvSpPr>
         <p:spPr>
           <a:xfrm>
-            <a:off x="1371600" y="3246120"/>
-            <a:ext cx="4434840" cy="1097280"/>
+            <a:off x="7863840" y="2606040"/>
+            <a:ext cx="3749040" cy="1097280"/>
           </a:xfrm>
           <a:prstGeom prst="rect">
             <a:avLst/>
@@ -3099,10 +3345,10 @@
             <a:r>
               <a:rPr lang="en-US" sz="1400" b="1" dirty="0">
                 <a:solidFill>
-                  <a:schemeClr val="tx1"/>
-                </a:solidFill>
-              </a:rPr>
-              <a:t>Strict cut-off for people</a:t>
+                  <a:srgbClr val="0F62FE"/>
+                </a:solidFill>
+              </a:rPr>
+              <a:t>Containerised</a:t>
             </a:r>
             <a:endParaRPr lang="en-US" sz="1400" dirty="0"/>
           </a:p>
@@ -3113,10 +3359,10 @@
             <a:r>
               <a:rPr lang="en-US" sz="1400" dirty="0">
                 <a:solidFill>
-                  <a:srgbClr val="525252"/>
-                </a:solidFill>
-              </a:rPr>
-              <a:t>Students are contacted only at the precision-weighted level; holds happen only there</a:t>
+                  <a:srgbClr val="161616"/>
+                </a:solidFill>
+              </a:rPr>
+              <a:t>Docker images on IBM's s390x base image, --restart unless-stopped: both came back on their own after a VM restart</a:t>
             </a:r>
             <a:endParaRPr lang="en-US" sz="1400" dirty="0"/>
           </a:p>
@@ -3124,102 +3370,14 @@
       </p:sp>
       <p:sp>
         <p:nvSpPr>
-          <p:cNvPr id="15" name="ethics 4"/>
-          <p:cNvSpPr/>
-          <p:nvPr/>
-        </p:nvSpPr>
-        <p:spPr>
-          <a:xfrm>
-            <a:off x="6172200" y="3063240"/>
-            <a:ext cx="5440680" cy="1417320"/>
-          </a:xfrm>
-          <a:prstGeom prst="roundRect">
-            <a:avLst>
-              <a:gd name="adj" fmla="val 7742"/>
-            </a:avLst>
-          </a:prstGeom>
-          <a:solidFill>
-            <a:srgbClr val="F2F4F8"/>
-          </a:solidFill>
-          <a:ln w="12700">
-            <a:solidFill>
-              <a:srgbClr val="F2F4F8"/>
-            </a:solidFill>
-            <a:prstDash val="solid"/>
-          </a:ln>
-        </p:spPr>
-      </p:sp>
-      <p:sp>
-        <p:nvSpPr>
-          <p:cNvPr id="16" name="tick 4"/>
-          <p:cNvSpPr/>
-          <p:nvPr/>
-        </p:nvSpPr>
-        <p:spPr>
-          <a:xfrm>
-            <a:off x="6400800" y="3337560"/>
-            <a:ext cx="411480" cy="411480"/>
-          </a:xfrm>
-          <a:prstGeom prst="ellipse">
-            <a:avLst/>
-          </a:prstGeom>
-          <a:solidFill>
-            <a:schemeClr val="accent4"/>
-          </a:solidFill>
-          <a:ln w="12700">
-            <a:solidFill>
-              <a:schemeClr val="accent4"/>
-            </a:solidFill>
-            <a:prstDash val="solid"/>
-          </a:ln>
-        </p:spPr>
-      </p:sp>
-      <p:sp>
-        <p:nvSpPr>
-          <p:cNvPr id="17" name="Text 15"/>
-          <p:cNvSpPr txBox="1"/>
-          <p:nvPr/>
-        </p:nvSpPr>
-        <p:spPr>
-          <a:xfrm>
-            <a:off x="6400800" y="3337560"/>
-            <a:ext cx="411480" cy="411480"/>
-          </a:xfrm>
-          <a:prstGeom prst="rect">
-            <a:avLst/>
-          </a:prstGeom>
-          <a:noFill/>
-          <a:ln/>
-        </p:spPr>
-        <p:txBody>
-          <a:bodyPr wrap="square" lIns="0" tIns="0" rIns="0" bIns="0" rtlCol="0" anchor="ctr"/>
-          <a:lstStyle/>
-          <a:p>
-            <a:pPr algn="ctr" indent="0" marL="0">
-              <a:buNone/>
-            </a:pPr>
-            <a:r>
-              <a:rPr lang="en-US" sz="1600" b="1" dirty="0">
-                <a:solidFill>
-                  <a:schemeClr val="bg1"/>
-                </a:solidFill>
-              </a:rPr>
-              <a:t>✓</a:t>
-            </a:r>
-            <a:endParaRPr lang="en-US" sz="1600" dirty="0"/>
-          </a:p>
-        </p:txBody>
-      </p:sp>
-      <p:sp>
-        <p:nvSpPr>
-          <p:cNvPr id="18" name="Text 16"/>
-          <p:cNvSpPr txBox="1"/>
-          <p:nvPr/>
-        </p:nvSpPr>
-        <p:spPr>
-          <a:xfrm>
-            <a:off x="6995160" y="3246120"/>
-            <a:ext cx="4434840" cy="1097280"/>
+          <p:cNvPr id="15" name="Text 13"/>
+          <p:cNvSpPr txBox="1"/>
+          <p:nvPr/>
+        </p:nvSpPr>
+        <p:spPr>
+          <a:xfrm>
+            <a:off x="7863840" y="3794760"/>
+            <a:ext cx="3749040" cy="1097280"/>
           </a:xfrm>
           <a:prstGeom prst="rect">
             <a:avLst/>
@@ -3237,10 +3395,10 @@
             <a:r>
               <a:rPr lang="en-US" sz="1400" b="1" dirty="0">
                 <a:solidFill>
-                  <a:schemeClr val="tx1"/>
-                </a:solidFill>
-              </a:rPr>
-              <a:t>No identity features</a:t>
+                  <a:srgbClr val="0F62FE"/>
+                </a:solidFill>
+              </a:rPr>
+              <a:t>Secure by design</a:t>
             </a:r>
             <a:endParaRPr lang="en-US" sz="1400" dirty="0"/>
           </a:p>
@@ -3251,10 +3409,10 @@
             <a:r>
               <a:rPr lang="en-US" sz="1400" dirty="0">
                 <a:solidFill>
-                  <a:srgbClr val="525252"/>
-                </a:solidFill>
-              </a:rPr>
-              <a:t>No age, nationality or ethnicity in the model; currency features flagged for a fairness check before real use</a:t>
+                  <a:srgbClr val="161616"/>
+                </a:solidFill>
+              </a:rPr>
+              <a:t>The model API sits on a private Docker network; only the web app is exposed</a:t>
             </a:r>
             <a:endParaRPr lang="en-US" sz="1400" dirty="0"/>
           </a:p>
@@ -3262,102 +3420,14 @@
       </p:sp>
       <p:sp>
         <p:nvSpPr>
-          <p:cNvPr id="19" name="ethics 5"/>
-          <p:cNvSpPr/>
-          <p:nvPr/>
-        </p:nvSpPr>
-        <p:spPr>
-          <a:xfrm>
-            <a:off x="548640" y="4663440"/>
-            <a:ext cx="5440680" cy="1417320"/>
-          </a:xfrm>
-          <a:prstGeom prst="roundRect">
-            <a:avLst>
-              <a:gd name="adj" fmla="val 7742"/>
-            </a:avLst>
-          </a:prstGeom>
-          <a:solidFill>
-            <a:srgbClr val="F2F4F8"/>
-          </a:solidFill>
-          <a:ln w="12700">
-            <a:solidFill>
-              <a:srgbClr val="F2F4F8"/>
-            </a:solidFill>
-            <a:prstDash val="solid"/>
-          </a:ln>
-        </p:spPr>
-      </p:sp>
-      <p:sp>
-        <p:nvSpPr>
-          <p:cNvPr id="20" name="tick 5"/>
-          <p:cNvSpPr/>
-          <p:nvPr/>
-        </p:nvSpPr>
-        <p:spPr>
-          <a:xfrm>
-            <a:off x="777240" y="4937760"/>
-            <a:ext cx="411480" cy="411480"/>
-          </a:xfrm>
-          <a:prstGeom prst="ellipse">
-            <a:avLst/>
-          </a:prstGeom>
-          <a:solidFill>
-            <a:schemeClr val="accent4"/>
-          </a:solidFill>
-          <a:ln w="12700">
-            <a:solidFill>
-              <a:schemeClr val="accent4"/>
-            </a:solidFill>
-            <a:prstDash val="solid"/>
-          </a:ln>
-        </p:spPr>
-      </p:sp>
-      <p:sp>
-        <p:nvSpPr>
-          <p:cNvPr id="21" name="Text 19"/>
-          <p:cNvSpPr txBox="1"/>
-          <p:nvPr/>
-        </p:nvSpPr>
-        <p:spPr>
-          <a:xfrm>
-            <a:off x="777240" y="4937760"/>
-            <a:ext cx="411480" cy="411480"/>
-          </a:xfrm>
-          <a:prstGeom prst="rect">
-            <a:avLst/>
-          </a:prstGeom>
-          <a:noFill/>
-          <a:ln/>
-        </p:spPr>
-        <p:txBody>
-          <a:bodyPr wrap="square" lIns="0" tIns="0" rIns="0" bIns="0" rtlCol="0" anchor="ctr"/>
-          <a:lstStyle/>
-          <a:p>
-            <a:pPr algn="ctr" indent="0" marL="0">
-              <a:buNone/>
-            </a:pPr>
-            <a:r>
-              <a:rPr lang="en-US" sz="1600" b="1" dirty="0">
-                <a:solidFill>
-                  <a:schemeClr val="bg1"/>
-                </a:solidFill>
-              </a:rPr>
-              <a:t>✓</a:t>
-            </a:r>
-            <a:endParaRPr lang="en-US" sz="1600" dirty="0"/>
-          </a:p>
-        </p:txBody>
-      </p:sp>
-      <p:sp>
-        <p:nvSpPr>
-          <p:cNvPr id="22" name="Text 20"/>
-          <p:cNvSpPr txBox="1"/>
-          <p:nvPr/>
-        </p:nvSpPr>
-        <p:spPr>
-          <a:xfrm>
-            <a:off x="1371600" y="4846320"/>
-            <a:ext cx="4434840" cy="1097280"/>
+          <p:cNvPr id="16" name="Text 14"/>
+          <p:cNvSpPr txBox="1"/>
+          <p:nvPr/>
+        </p:nvSpPr>
+        <p:spPr>
+          <a:xfrm>
+            <a:off x="7863840" y="4983480"/>
+            <a:ext cx="3749040" cy="1097280"/>
           </a:xfrm>
           <a:prstGeom prst="rect">
             <a:avLst/>
@@ -3375,10 +3445,10 @@
             <a:r>
               <a:rPr lang="en-US" sz="1400" b="1" dirty="0">
                 <a:solidFill>
-                  <a:schemeClr val="tx1"/>
-                </a:solidFill>
-              </a:rPr>
-              <a:t>Honest evaluation</a:t>
+                  <a:srgbClr val="0F62FE"/>
+                </a:solidFill>
+              </a:rPr>
+              <a:t>Real-time</a:t>
             </a:r>
             <a:endParaRPr lang="en-US" sz="1400" dirty="0"/>
           </a:p>
@@ -3389,148 +3459,10 @@
             <a:r>
               <a:rPr lang="en-US" sz="1400" dirty="0">
                 <a:solidFill>
-                  <a:srgbClr val="525252"/>
-                </a:solidFill>
-              </a:rPr>
-              <a:t>Synthetic data labelled as such; test set used once; the failed Isolation Forest result reported</a:t>
-            </a:r>
-            <a:endParaRPr lang="en-US" sz="1400" dirty="0"/>
-          </a:p>
-        </p:txBody>
-      </p:sp>
-      <p:sp>
-        <p:nvSpPr>
-          <p:cNvPr id="23" name="ethics 6"/>
-          <p:cNvSpPr/>
-          <p:nvPr/>
-        </p:nvSpPr>
-        <p:spPr>
-          <a:xfrm>
-            <a:off x="6172200" y="4663440"/>
-            <a:ext cx="5440680" cy="1417320"/>
-          </a:xfrm>
-          <a:prstGeom prst="roundRect">
-            <a:avLst>
-              <a:gd name="adj" fmla="val 7742"/>
-            </a:avLst>
-          </a:prstGeom>
-          <a:solidFill>
-            <a:srgbClr val="F2F4F8"/>
-          </a:solidFill>
-          <a:ln w="12700">
-            <a:solidFill>
-              <a:srgbClr val="F2F4F8"/>
-            </a:solidFill>
-            <a:prstDash val="solid"/>
-          </a:ln>
-        </p:spPr>
-      </p:sp>
-      <p:sp>
-        <p:nvSpPr>
-          <p:cNvPr id="24" name="tick 6"/>
-          <p:cNvSpPr/>
-          <p:nvPr/>
-        </p:nvSpPr>
-        <p:spPr>
-          <a:xfrm>
-            <a:off x="6400800" y="4937760"/>
-            <a:ext cx="411480" cy="411480"/>
-          </a:xfrm>
-          <a:prstGeom prst="ellipse">
-            <a:avLst/>
-          </a:prstGeom>
-          <a:solidFill>
-            <a:schemeClr val="accent4"/>
-          </a:solidFill>
-          <a:ln w="12700">
-            <a:solidFill>
-              <a:schemeClr val="accent4"/>
-            </a:solidFill>
-            <a:prstDash val="solid"/>
-          </a:ln>
-        </p:spPr>
-      </p:sp>
-      <p:sp>
-        <p:nvSpPr>
-          <p:cNvPr id="25" name="Text 23"/>
-          <p:cNvSpPr txBox="1"/>
-          <p:nvPr/>
-        </p:nvSpPr>
-        <p:spPr>
-          <a:xfrm>
-            <a:off x="6400800" y="4937760"/>
-            <a:ext cx="411480" cy="411480"/>
-          </a:xfrm>
-          <a:prstGeom prst="rect">
-            <a:avLst/>
-          </a:prstGeom>
-          <a:noFill/>
-          <a:ln/>
-        </p:spPr>
-        <p:txBody>
-          <a:bodyPr wrap="square" lIns="0" tIns="0" rIns="0" bIns="0" rtlCol="0" anchor="ctr"/>
-          <a:lstStyle/>
-          <a:p>
-            <a:pPr algn="ctr" indent="0" marL="0">
-              <a:buNone/>
-            </a:pPr>
-            <a:r>
-              <a:rPr lang="en-US" sz="1600" b="1" dirty="0">
-                <a:solidFill>
-                  <a:schemeClr val="bg1"/>
-                </a:solidFill>
-              </a:rPr>
-              <a:t>✓</a:t>
-            </a:r>
-            <a:endParaRPr lang="en-US" sz="1600" dirty="0"/>
-          </a:p>
-        </p:txBody>
-      </p:sp>
-      <p:sp>
-        <p:nvSpPr>
-          <p:cNvPr id="26" name="Text 24"/>
-          <p:cNvSpPr txBox="1"/>
-          <p:nvPr/>
-        </p:nvSpPr>
-        <p:spPr>
-          <a:xfrm>
-            <a:off x="6995160" y="4846320"/>
-            <a:ext cx="4434840" cy="1097280"/>
-          </a:xfrm>
-          <a:prstGeom prst="rect">
-            <a:avLst/>
-          </a:prstGeom>
-          <a:noFill/>
-          <a:ln/>
-        </p:spPr>
-        <p:txBody>
-          <a:bodyPr wrap="square" lIns="0" tIns="0" rIns="0" bIns="0" rtlCol="0" anchor="t"/>
-          <a:lstStyle/>
-          <a:p>
-            <a:pPr indent="0" marL="0">
-              <a:buNone/>
-            </a:pPr>
-            <a:r>
-              <a:rPr lang="en-US" sz="1400" b="1" dirty="0">
-                <a:solidFill>
-                  <a:schemeClr val="tx1"/>
-                </a:solidFill>
-              </a:rPr>
-              <a:t>Privacy</a:t>
-            </a:r>
-            <a:endParaRPr lang="en-US" sz="1400" dirty="0"/>
-          </a:p>
-          <a:p>
-            <a:pPr indent="0" marL="0">
-              <a:buNone/>
-            </a:pPr>
-            <a:r>
-              <a:rPr lang="en-US" sz="1400" dirty="0">
-                <a:solidFill>
-                  <a:srgbClr val="525252"/>
-                </a:solidFill>
-              </a:rPr>
-              <a:t>Synthetic data, no real customers; scoring stays on the platform, nothing sent to outside services</a:t>
+                  <a:srgbClr val="161616"/>
+                </a:solidFill>
+              </a:rPr>
+              <a:t>0.55 ms per payment measured; stateless scoring scales out with more replicas</a:t>
             </a:r>
             <a:endParaRPr lang="en-US" sz="1400" dirty="0"/>
           </a:p>
@@ -3616,6 +3548,1290 @@
         </p:nvSpPr>
         <p:spPr>
           <a:xfrm>
+            <a:off x="548640" y="365760"/>
+            <a:ext cx="11064240" cy="822960"/>
+          </a:xfrm>
+          <a:prstGeom prst="rect">
+            <a:avLst/>
+          </a:prstGeom>
+          <a:noFill/>
+          <a:ln/>
+        </p:spPr>
+        <p:txBody>
+          <a:bodyPr wrap="square" lIns="0" tIns="0" rIns="0" bIns="0" rtlCol="0" anchor="t"/>
+          <a:lstStyle/>
+          <a:p>
+            <a:pPr algn="l" indent="0" marL="0">
+              <a:buNone/>
+            </a:pPr>
+            <a:r>
+              <a:rPr lang="en-US" sz="3200" b="1" dirty="0">
+                <a:solidFill>
+                  <a:schemeClr val="tx1"/>
+                </a:solidFill>
+              </a:rPr>
+              <a:t>Evidence: it runs on IBM LinuxONE</a:t>
+            </a:r>
+            <a:endParaRPr lang="en-US" sz="3200" dirty="0"/>
+          </a:p>
+        </p:txBody>
+      </p:sp>
+      <p:pic>
+        <p:nvPicPr>
+          <p:cNvPr id="3" name="dashboard" descr="/home/claude/shots/01_linuxone_dashboard.png">    </p:cNvPr>
+          <p:cNvPicPr>
+            <a:picLocks noChangeAspect="1"/>
+          </p:cNvPicPr>
+          <p:nvPr/>
+        </p:nvPicPr>
+        <p:blipFill>
+          <a:blip r:embed="rId1"/>
+          <a:stretch>
+            <a:fillRect/>
+          </a:stretch>
+        </p:blipFill>
+        <p:spPr>
+          <a:xfrm>
+            <a:off x="548640" y="1234440"/>
+            <a:ext cx="5486400" cy="1768510"/>
+          </a:xfrm>
+          <a:prstGeom prst="rect">
+            <a:avLst/>
+          </a:prstGeom>
+        </p:spPr>
+      </p:pic>
+      <p:sp>
+        <p:nvSpPr>
+          <p:cNvPr id="4" name="Text 1"/>
+          <p:cNvSpPr txBox="1"/>
+          <p:nvPr/>
+        </p:nvSpPr>
+        <p:spPr>
+          <a:xfrm>
+            <a:off x="548640" y="3063240"/>
+            <a:ext cx="5486400" cy="274320"/>
+          </a:xfrm>
+          <a:prstGeom prst="rect">
+            <a:avLst/>
+          </a:prstGeom>
+          <a:noFill/>
+          <a:ln/>
+        </p:spPr>
+        <p:txBody>
+          <a:bodyPr wrap="square" lIns="0" tIns="0" rIns="0" bIns="0" rtlCol="0" anchor="ctr"/>
+          <a:lstStyle/>
+          <a:p>
+            <a:pPr indent="0" marL="0">
+              <a:buNone/>
+            </a:pPr>
+            <a:r>
+              <a:rPr lang="en-US" sz="1100" dirty="0">
+                <a:solidFill>
+                  <a:srgbClr val="525252"/>
+                </a:solidFill>
+              </a:rPr>
+              <a:t>LinuxONE Community Cloud: HulmeAI VM, active</a:t>
+            </a:r>
+            <a:endParaRPr lang="en-US" sz="1100" dirty="0"/>
+          </a:p>
+        </p:txBody>
+      </p:sp>
+      <p:pic>
+        <p:nvPicPr>
+          <p:cNvPr id="5" name="health" descr="/home/claude/shots/02_health.png">    </p:cNvPr>
+          <p:cNvPicPr>
+            <a:picLocks noChangeAspect="1"/>
+          </p:cNvPicPr>
+          <p:nvPr/>
+        </p:nvPicPr>
+        <p:blipFill>
+          <a:blip r:embed="rId2"/>
+          <a:stretch>
+            <a:fillRect/>
+          </a:stretch>
+        </p:blipFill>
+        <p:spPr>
+          <a:xfrm>
+            <a:off x="548640" y="3566160"/>
+            <a:ext cx="5486400" cy="297712"/>
+          </a:xfrm>
+          <a:prstGeom prst="rect">
+            <a:avLst/>
+          </a:prstGeom>
+        </p:spPr>
+      </p:pic>
+      <p:sp>
+        <p:nvSpPr>
+          <p:cNvPr id="6" name="Text 2"/>
+          <p:cNvSpPr txBox="1"/>
+          <p:nvPr/>
+        </p:nvSpPr>
+        <p:spPr>
+          <a:xfrm>
+            <a:off x="548640" y="3931920"/>
+            <a:ext cx="5486400" cy="274320"/>
+          </a:xfrm>
+          <a:prstGeom prst="rect">
+            <a:avLst/>
+          </a:prstGeom>
+          <a:noFill/>
+          <a:ln/>
+        </p:spPr>
+        <p:txBody>
+          <a:bodyPr wrap="square" lIns="0" tIns="0" rIns="0" bIns="0" rtlCol="0" anchor="ctr"/>
+          <a:lstStyle/>
+          <a:p>
+            <a:pPr indent="0" marL="0">
+              <a:buNone/>
+            </a:pPr>
+            <a:r>
+              <a:rPr lang="en-US" sz="1100" dirty="0">
+                <a:solidFill>
+                  <a:srgbClr val="525252"/>
+                </a:solidFill>
+              </a:rPr>
+              <a:t>Live /health: machine s390x, 25 features, both cut-offs</a:t>
+            </a:r>
+            <a:endParaRPr lang="en-US" sz="1100" dirty="0"/>
+          </a:p>
+        </p:txBody>
+      </p:sp>
+      <p:pic>
+        <p:nvPicPr>
+          <p:cNvPr id="7" name="live" descr="/home/claude/shots/08_live_replay.png">    </p:cNvPr>
+          <p:cNvPicPr>
+            <a:picLocks noChangeAspect="1"/>
+          </p:cNvPicPr>
+          <p:nvPr/>
+        </p:nvPicPr>
+        <p:blipFill>
+          <a:blip r:embed="rId3"/>
+          <a:stretch>
+            <a:fillRect/>
+          </a:stretch>
+        </p:blipFill>
+        <p:spPr>
+          <a:xfrm>
+            <a:off x="548640" y="4343400"/>
+            <a:ext cx="3401568" cy="1917142"/>
+          </a:xfrm>
+          <a:prstGeom prst="rect">
+            <a:avLst/>
+          </a:prstGeom>
+        </p:spPr>
+      </p:pic>
+      <p:sp>
+        <p:nvSpPr>
+          <p:cNvPr id="8" name="Text 3"/>
+          <p:cNvSpPr txBox="1"/>
+          <p:nvPr/>
+        </p:nvSpPr>
+        <p:spPr>
+          <a:xfrm>
+            <a:off x="4069080" y="4754880"/>
+            <a:ext cx="2011680" cy="914400"/>
+          </a:xfrm>
+          <a:prstGeom prst="rect">
+            <a:avLst/>
+          </a:prstGeom>
+          <a:noFill/>
+          <a:ln/>
+        </p:spPr>
+        <p:txBody>
+          <a:bodyPr wrap="square" lIns="0" tIns="0" rIns="0" bIns="0" rtlCol="0" anchor="t"/>
+          <a:lstStyle/>
+          <a:p>
+            <a:pPr indent="0" marL="0">
+              <a:buNone/>
+            </a:pPr>
+            <a:r>
+              <a:rPr lang="en-US" sz="1100" dirty="0">
+                <a:solidFill>
+                  <a:srgbClr val="525252"/>
+                </a:solidFill>
+              </a:rPr>
+              <a:t>/live replay: 0.55 ms average per payment</a:t>
+            </a:r>
+            <a:endParaRPr lang="en-US" sz="1100" dirty="0"/>
+          </a:p>
+        </p:txBody>
+      </p:sp>
+      <p:pic>
+        <p:nvPicPr>
+          <p:cNvPr id="9" name="notebook" descr="/home/claude/shots/03_notebook03_training.png">    </p:cNvPr>
+          <p:cNvPicPr>
+            <a:picLocks noChangeAspect="1"/>
+          </p:cNvPicPr>
+          <p:nvPr/>
+        </p:nvPicPr>
+        <p:blipFill>
+          <a:blip r:embed="rId4"/>
+          <a:stretch>
+            <a:fillRect/>
+          </a:stretch>
+        </p:blipFill>
+        <p:spPr>
+          <a:xfrm>
+            <a:off x="6355080" y="1234440"/>
+            <a:ext cx="5257800" cy="2963325"/>
+          </a:xfrm>
+          <a:prstGeom prst="rect">
+            <a:avLst/>
+          </a:prstGeom>
+        </p:spPr>
+      </p:pic>
+      <p:sp>
+        <p:nvSpPr>
+          <p:cNvPr id="10" name="Text 4"/>
+          <p:cNvSpPr txBox="1"/>
+          <p:nvPr/>
+        </p:nvSpPr>
+        <p:spPr>
+          <a:xfrm>
+            <a:off x="6355080" y="4251960"/>
+            <a:ext cx="5257800" cy="274320"/>
+          </a:xfrm>
+          <a:prstGeom prst="rect">
+            <a:avLst/>
+          </a:prstGeom>
+          <a:noFill/>
+          <a:ln/>
+        </p:spPr>
+        <p:txBody>
+          <a:bodyPr wrap="square" lIns="0" tIns="0" rIns="0" bIns="0" rtlCol="0" anchor="ctr"/>
+          <a:lstStyle/>
+          <a:p>
+            <a:pPr indent="0" marL="0">
+              <a:buNone/>
+            </a:pPr>
+            <a:r>
+              <a:rPr lang="en-US" sz="1100" dirty="0">
+                <a:solidFill>
+                  <a:srgbClr val="525252"/>
+                </a:solidFill>
+              </a:rPr>
+              <a:t>Notebook 03 on LinuxONE: XGBoost trained on s390x in 19.0 s</a:t>
+            </a:r>
+            <a:endParaRPr lang="en-US" sz="1100" dirty="0"/>
+          </a:p>
+        </p:txBody>
+      </p:sp>
+      <p:sp>
+        <p:nvSpPr>
+          <p:cNvPr id="25" name="Slide Number Placeholder 0"/>
+          <p:cNvSpPr>
+            <a:spLocks noGrp="1"/>
+          </p:cNvSpPr>
+          <p:nvPr>
+            <p:ph type="sldNum" sz="quarter" idx="4294967295"/>
+          </p:nvPr>
+        </p:nvSpPr>
+        <p:spPr>
+          <a:xfrm>
+            <a:off x="11247120" y="6400800"/>
+            <a:ext cx="457200" cy="274320"/>
+          </a:xfrm>
+          <a:prstGeom prst="rect">
+            <a:avLst/>
+          </a:prstGeom>
+          <a:extLst>
+            <a:ext uri="{C572A759-6A51-4108-AA02-DFA0A04FC94B}">
+              <ma14:wrappingTextBoxFlag xmlns:ma14="http://schemas.microsoft.com/office/mac/drawingml/2011/main" val="0"/>
+            </a:ext>
+          </a:extLst>
+        </p:spPr>
+        <p:txBody>
+          <a:bodyPr/>
+          <a:lstStyle>
+            <a:lvl1pPr>
+              <a:defRPr sz="1000">
+                <a:solidFill>
+                  <a:srgbClr val="6F6F6F"/>
+                </a:solidFill>
+              </a:defRPr>
+            </a:lvl1pPr>
+          </a:lstStyle>
+          <a:p>
+            <a:pPr algn="r"/>
+            <a:fld id="{F7021451-1387-4CA6-816F-3879F97B5CBC}" type="slidenum">
+              <a:rPr b="0" lang="en-US"/>
+              <a:t>11</a:t>
+            </a:fld>
+            <a:endParaRPr lang="en-US"/>
+          </a:p>
+        </p:txBody>
+      </p:sp>
+    </p:spTree>
+  </p:cSld>
+  <p:clrMapOvr>
+    <a:masterClrMapping/>
+  </p:clrMapOvr>
+</p:sld>
+</file>
+
+<file path=ppt/slides/slide12.xml><?xml version="1.0" encoding="utf-8"?>
+<p:sld xmlns:a="http://schemas.openxmlformats.org/drawingml/2006/main" xmlns:r="http://schemas.openxmlformats.org/officeDocument/2006/relationships" xmlns:p="http://schemas.openxmlformats.org/presentationml/2006/main">
+  <p:cSld name="Slide 12">
+    <p:spTree>
+      <p:nvGrpSpPr>
+        <p:cNvPr id="1" name=""/>
+        <p:cNvGrpSpPr/>
+        <p:nvPr/>
+      </p:nvGrpSpPr>
+      <p:grpSpPr>
+        <a:xfrm>
+          <a:off x="0" y="0"/>
+          <a:ext cx="0" cy="0"/>
+          <a:chOff x="0" y="0"/>
+          <a:chExt cx="0" cy="0"/>
+        </a:xfrm>
+      </p:grpSpPr>
+      <p:sp>
+        <p:nvSpPr>
+          <p:cNvPr id="2" name="Text 0"/>
+          <p:cNvSpPr/>
+          <p:nvPr>
+            <p:ph idx="100" type="title" hasCustomPrompt="1"/>
+          </p:nvPr>
+        </p:nvSpPr>
+        <p:spPr>
+          <a:xfrm>
+            <a:off x="548640" y="365760"/>
+            <a:ext cx="11064240" cy="822960"/>
+          </a:xfrm>
+          <a:prstGeom prst="rect">
+            <a:avLst/>
+          </a:prstGeom>
+          <a:noFill/>
+          <a:ln/>
+        </p:spPr>
+        <p:txBody>
+          <a:bodyPr wrap="square" lIns="0" tIns="0" rIns="0" bIns="0" rtlCol="0" anchor="t"/>
+          <a:lstStyle/>
+          <a:p>
+            <a:pPr algn="l" indent="0" marL="0">
+              <a:buNone/>
+            </a:pPr>
+            <a:r>
+              <a:rPr lang="en-US" sz="3200" b="1" dirty="0">
+                <a:solidFill>
+                  <a:schemeClr val="tx1"/>
+                </a:solidFill>
+              </a:rPr>
+              <a:t>Designed to protect students, not accuse them</a:t>
+            </a:r>
+            <a:endParaRPr lang="en-US" sz="3200" dirty="0"/>
+          </a:p>
+        </p:txBody>
+      </p:sp>
+      <p:sp>
+        <p:nvSpPr>
+          <p:cNvPr id="3" name="ethics 1"/>
+          <p:cNvSpPr/>
+          <p:nvPr/>
+        </p:nvSpPr>
+        <p:spPr>
+          <a:xfrm>
+            <a:off x="548640" y="1463040"/>
+            <a:ext cx="5440680" cy="1417320"/>
+          </a:xfrm>
+          <a:prstGeom prst="roundRect">
+            <a:avLst>
+              <a:gd name="adj" fmla="val 7742"/>
+            </a:avLst>
+          </a:prstGeom>
+          <a:solidFill>
+            <a:srgbClr val="F2F4F8"/>
+          </a:solidFill>
+          <a:ln w="12700">
+            <a:solidFill>
+              <a:srgbClr val="F2F4F8"/>
+            </a:solidFill>
+            <a:prstDash val="solid"/>
+          </a:ln>
+        </p:spPr>
+      </p:sp>
+      <p:sp>
+        <p:nvSpPr>
+          <p:cNvPr id="4" name="tick 1"/>
+          <p:cNvSpPr/>
+          <p:nvPr/>
+        </p:nvSpPr>
+        <p:spPr>
+          <a:xfrm>
+            <a:off x="777240" y="1737360"/>
+            <a:ext cx="411480" cy="411480"/>
+          </a:xfrm>
+          <a:prstGeom prst="ellipse">
+            <a:avLst/>
+          </a:prstGeom>
+          <a:solidFill>
+            <a:schemeClr val="accent4"/>
+          </a:solidFill>
+          <a:ln w="12700">
+            <a:solidFill>
+              <a:schemeClr val="accent4"/>
+            </a:solidFill>
+            <a:prstDash val="solid"/>
+          </a:ln>
+        </p:spPr>
+      </p:sp>
+      <p:sp>
+        <p:nvSpPr>
+          <p:cNvPr id="5" name="Text 3"/>
+          <p:cNvSpPr txBox="1"/>
+          <p:nvPr/>
+        </p:nvSpPr>
+        <p:spPr>
+          <a:xfrm>
+            <a:off x="777240" y="1737360"/>
+            <a:ext cx="411480" cy="411480"/>
+          </a:xfrm>
+          <a:prstGeom prst="rect">
+            <a:avLst/>
+          </a:prstGeom>
+          <a:noFill/>
+          <a:ln/>
+        </p:spPr>
+        <p:txBody>
+          <a:bodyPr wrap="square" lIns="0" tIns="0" rIns="0" bIns="0" rtlCol="0" anchor="ctr"/>
+          <a:lstStyle/>
+          <a:p>
+            <a:pPr algn="ctr" indent="0" marL="0">
+              <a:buNone/>
+            </a:pPr>
+            <a:r>
+              <a:rPr lang="en-US" sz="1600" b="1" dirty="0">
+                <a:solidFill>
+                  <a:schemeClr val="bg1"/>
+                </a:solidFill>
+              </a:rPr>
+              <a:t>✓</a:t>
+            </a:r>
+            <a:endParaRPr lang="en-US" sz="1600" dirty="0"/>
+          </a:p>
+        </p:txBody>
+      </p:sp>
+      <p:sp>
+        <p:nvSpPr>
+          <p:cNvPr id="6" name="Text 4"/>
+          <p:cNvSpPr txBox="1"/>
+          <p:nvPr/>
+        </p:nvSpPr>
+        <p:spPr>
+          <a:xfrm>
+            <a:off x="1371600" y="1645920"/>
+            <a:ext cx="4434840" cy="1097280"/>
+          </a:xfrm>
+          <a:prstGeom prst="rect">
+            <a:avLst/>
+          </a:prstGeom>
+          <a:noFill/>
+          <a:ln/>
+        </p:spPr>
+        <p:txBody>
+          <a:bodyPr wrap="square" lIns="0" tIns="0" rIns="0" bIns="0" rtlCol="0" anchor="t"/>
+          <a:lstStyle/>
+          <a:p>
+            <a:pPr indent="0" marL="0">
+              <a:buNone/>
+            </a:pPr>
+            <a:r>
+              <a:rPr lang="en-US" sz="1400" b="1" dirty="0">
+                <a:solidFill>
+                  <a:schemeClr val="tx1"/>
+                </a:solidFill>
+              </a:rPr>
+              <a:t>No tipping off</a:t>
+            </a:r>
+            <a:endParaRPr lang="en-US" sz="1400" dirty="0"/>
+          </a:p>
+          <a:p>
+            <a:pPr indent="0" marL="0">
+              <a:buNone/>
+            </a:pPr>
+            <a:r>
+              <a:rPr lang="en-US" sz="1400" dirty="0">
+                <a:solidFill>
+                  <a:srgbClr val="525252"/>
+                </a:solidFill>
+              </a:rPr>
+              <a:t>The phone never shows a score, reason or suspicion: only a safeguarding question banks already ask</a:t>
+            </a:r>
+            <a:endParaRPr lang="en-US" sz="1400" dirty="0"/>
+          </a:p>
+        </p:txBody>
+      </p:sp>
+      <p:sp>
+        <p:nvSpPr>
+          <p:cNvPr id="7" name="ethics 2"/>
+          <p:cNvSpPr/>
+          <p:nvPr/>
+        </p:nvSpPr>
+        <p:spPr>
+          <a:xfrm>
+            <a:off x="6172200" y="1463040"/>
+            <a:ext cx="5440680" cy="1417320"/>
+          </a:xfrm>
+          <a:prstGeom prst="roundRect">
+            <a:avLst>
+              <a:gd name="adj" fmla="val 7742"/>
+            </a:avLst>
+          </a:prstGeom>
+          <a:solidFill>
+            <a:srgbClr val="F2F4F8"/>
+          </a:solidFill>
+          <a:ln w="12700">
+            <a:solidFill>
+              <a:srgbClr val="F2F4F8"/>
+            </a:solidFill>
+            <a:prstDash val="solid"/>
+          </a:ln>
+        </p:spPr>
+      </p:sp>
+      <p:sp>
+        <p:nvSpPr>
+          <p:cNvPr id="8" name="tick 2"/>
+          <p:cNvSpPr/>
+          <p:nvPr/>
+        </p:nvSpPr>
+        <p:spPr>
+          <a:xfrm>
+            <a:off x="6400800" y="1737360"/>
+            <a:ext cx="411480" cy="411480"/>
+          </a:xfrm>
+          <a:prstGeom prst="ellipse">
+            <a:avLst/>
+          </a:prstGeom>
+          <a:solidFill>
+            <a:schemeClr val="accent4"/>
+          </a:solidFill>
+          <a:ln w="12700">
+            <a:solidFill>
+              <a:schemeClr val="accent4"/>
+            </a:solidFill>
+            <a:prstDash val="solid"/>
+          </a:ln>
+        </p:spPr>
+      </p:sp>
+      <p:sp>
+        <p:nvSpPr>
+          <p:cNvPr id="9" name="Text 7"/>
+          <p:cNvSpPr txBox="1"/>
+          <p:nvPr/>
+        </p:nvSpPr>
+        <p:spPr>
+          <a:xfrm>
+            <a:off x="6400800" y="1737360"/>
+            <a:ext cx="411480" cy="411480"/>
+          </a:xfrm>
+          <a:prstGeom prst="rect">
+            <a:avLst/>
+          </a:prstGeom>
+          <a:noFill/>
+          <a:ln/>
+        </p:spPr>
+        <p:txBody>
+          <a:bodyPr wrap="square" lIns="0" tIns="0" rIns="0" bIns="0" rtlCol="0" anchor="ctr"/>
+          <a:lstStyle/>
+          <a:p>
+            <a:pPr algn="ctr" indent="0" marL="0">
+              <a:buNone/>
+            </a:pPr>
+            <a:r>
+              <a:rPr lang="en-US" sz="1600" b="1" dirty="0">
+                <a:solidFill>
+                  <a:schemeClr val="bg1"/>
+                </a:solidFill>
+              </a:rPr>
+              <a:t>✓</a:t>
+            </a:r>
+            <a:endParaRPr lang="en-US" sz="1600" dirty="0"/>
+          </a:p>
+        </p:txBody>
+      </p:sp>
+      <p:sp>
+        <p:nvSpPr>
+          <p:cNvPr id="10" name="Text 8"/>
+          <p:cNvSpPr txBox="1"/>
+          <p:nvPr/>
+        </p:nvSpPr>
+        <p:spPr>
+          <a:xfrm>
+            <a:off x="6995160" y="1645920"/>
+            <a:ext cx="4434840" cy="1097280"/>
+          </a:xfrm>
+          <a:prstGeom prst="rect">
+            <a:avLst/>
+          </a:prstGeom>
+          <a:noFill/>
+          <a:ln/>
+        </p:spPr>
+        <p:txBody>
+          <a:bodyPr wrap="square" lIns="0" tIns="0" rIns="0" bIns="0" rtlCol="0" anchor="t"/>
+          <a:lstStyle/>
+          <a:p>
+            <a:pPr indent="0" marL="0">
+              <a:buNone/>
+            </a:pPr>
+            <a:r>
+              <a:rPr lang="en-US" sz="1400" b="1" dirty="0">
+                <a:solidFill>
+                  <a:schemeClr val="tx1"/>
+                </a:solidFill>
+              </a:rPr>
+              <a:t>A person decides</a:t>
+            </a:r>
+            <a:endParaRPr lang="en-US" sz="1400" dirty="0"/>
+          </a:p>
+          <a:p>
+            <a:pPr indent="0" marL="0">
+              <a:buNone/>
+            </a:pPr>
+            <a:r>
+              <a:rPr lang="en-US" sz="1400" dirty="0">
+                <a:solidFill>
+                  <a:srgbClr val="525252"/>
+                </a:solidFill>
+              </a:rPr>
+              <a:t>The model never freezes an account or files a report; an analyst reviews every alert</a:t>
+            </a:r>
+            <a:endParaRPr lang="en-US" sz="1400" dirty="0"/>
+          </a:p>
+        </p:txBody>
+      </p:sp>
+      <p:sp>
+        <p:nvSpPr>
+          <p:cNvPr id="11" name="ethics 3"/>
+          <p:cNvSpPr/>
+          <p:nvPr/>
+        </p:nvSpPr>
+        <p:spPr>
+          <a:xfrm>
+            <a:off x="548640" y="3063240"/>
+            <a:ext cx="5440680" cy="1417320"/>
+          </a:xfrm>
+          <a:prstGeom prst="roundRect">
+            <a:avLst>
+              <a:gd name="adj" fmla="val 7742"/>
+            </a:avLst>
+          </a:prstGeom>
+          <a:solidFill>
+            <a:srgbClr val="F2F4F8"/>
+          </a:solidFill>
+          <a:ln w="12700">
+            <a:solidFill>
+              <a:srgbClr val="F2F4F8"/>
+            </a:solidFill>
+            <a:prstDash val="solid"/>
+          </a:ln>
+        </p:spPr>
+      </p:sp>
+      <p:sp>
+        <p:nvSpPr>
+          <p:cNvPr id="12" name="tick 3"/>
+          <p:cNvSpPr/>
+          <p:nvPr/>
+        </p:nvSpPr>
+        <p:spPr>
+          <a:xfrm>
+            <a:off x="777240" y="3337560"/>
+            <a:ext cx="411480" cy="411480"/>
+          </a:xfrm>
+          <a:prstGeom prst="ellipse">
+            <a:avLst/>
+          </a:prstGeom>
+          <a:solidFill>
+            <a:schemeClr val="accent4"/>
+          </a:solidFill>
+          <a:ln w="12700">
+            <a:solidFill>
+              <a:schemeClr val="accent4"/>
+            </a:solidFill>
+            <a:prstDash val="solid"/>
+          </a:ln>
+        </p:spPr>
+      </p:sp>
+      <p:sp>
+        <p:nvSpPr>
+          <p:cNvPr id="13" name="Text 11"/>
+          <p:cNvSpPr txBox="1"/>
+          <p:nvPr/>
+        </p:nvSpPr>
+        <p:spPr>
+          <a:xfrm>
+            <a:off x="777240" y="3337560"/>
+            <a:ext cx="411480" cy="411480"/>
+          </a:xfrm>
+          <a:prstGeom prst="rect">
+            <a:avLst/>
+          </a:prstGeom>
+          <a:noFill/>
+          <a:ln/>
+        </p:spPr>
+        <p:txBody>
+          <a:bodyPr wrap="square" lIns="0" tIns="0" rIns="0" bIns="0" rtlCol="0" anchor="ctr"/>
+          <a:lstStyle/>
+          <a:p>
+            <a:pPr algn="ctr" indent="0" marL="0">
+              <a:buNone/>
+            </a:pPr>
+            <a:r>
+              <a:rPr lang="en-US" sz="1600" b="1" dirty="0">
+                <a:solidFill>
+                  <a:schemeClr val="bg1"/>
+                </a:solidFill>
+              </a:rPr>
+              <a:t>✓</a:t>
+            </a:r>
+            <a:endParaRPr lang="en-US" sz="1600" dirty="0"/>
+          </a:p>
+        </p:txBody>
+      </p:sp>
+      <p:sp>
+        <p:nvSpPr>
+          <p:cNvPr id="14" name="Text 12"/>
+          <p:cNvSpPr txBox="1"/>
+          <p:nvPr/>
+        </p:nvSpPr>
+        <p:spPr>
+          <a:xfrm>
+            <a:off x="1371600" y="3246120"/>
+            <a:ext cx="4434840" cy="1097280"/>
+          </a:xfrm>
+          <a:prstGeom prst="rect">
+            <a:avLst/>
+          </a:prstGeom>
+          <a:noFill/>
+          <a:ln/>
+        </p:spPr>
+        <p:txBody>
+          <a:bodyPr wrap="square" lIns="0" tIns="0" rIns="0" bIns="0" rtlCol="0" anchor="t"/>
+          <a:lstStyle/>
+          <a:p>
+            <a:pPr indent="0" marL="0">
+              <a:buNone/>
+            </a:pPr>
+            <a:r>
+              <a:rPr lang="en-US" sz="1400" b="1" dirty="0">
+                <a:solidFill>
+                  <a:schemeClr val="tx1"/>
+                </a:solidFill>
+              </a:rPr>
+              <a:t>Strict cut-off for people</a:t>
+            </a:r>
+            <a:endParaRPr lang="en-US" sz="1400" dirty="0"/>
+          </a:p>
+          <a:p>
+            <a:pPr indent="0" marL="0">
+              <a:buNone/>
+            </a:pPr>
+            <a:r>
+              <a:rPr lang="en-US" sz="1400" dirty="0">
+                <a:solidFill>
+                  <a:srgbClr val="525252"/>
+                </a:solidFill>
+              </a:rPr>
+              <a:t>Students are contacted only at the precision-weighted level; holds happen only there</a:t>
+            </a:r>
+            <a:endParaRPr lang="en-US" sz="1400" dirty="0"/>
+          </a:p>
+        </p:txBody>
+      </p:sp>
+      <p:sp>
+        <p:nvSpPr>
+          <p:cNvPr id="15" name="ethics 4"/>
+          <p:cNvSpPr/>
+          <p:nvPr/>
+        </p:nvSpPr>
+        <p:spPr>
+          <a:xfrm>
+            <a:off x="6172200" y="3063240"/>
+            <a:ext cx="5440680" cy="1417320"/>
+          </a:xfrm>
+          <a:prstGeom prst="roundRect">
+            <a:avLst>
+              <a:gd name="adj" fmla="val 7742"/>
+            </a:avLst>
+          </a:prstGeom>
+          <a:solidFill>
+            <a:srgbClr val="F2F4F8"/>
+          </a:solidFill>
+          <a:ln w="12700">
+            <a:solidFill>
+              <a:srgbClr val="F2F4F8"/>
+            </a:solidFill>
+            <a:prstDash val="solid"/>
+          </a:ln>
+        </p:spPr>
+      </p:sp>
+      <p:sp>
+        <p:nvSpPr>
+          <p:cNvPr id="16" name="tick 4"/>
+          <p:cNvSpPr/>
+          <p:nvPr/>
+        </p:nvSpPr>
+        <p:spPr>
+          <a:xfrm>
+            <a:off x="6400800" y="3337560"/>
+            <a:ext cx="411480" cy="411480"/>
+          </a:xfrm>
+          <a:prstGeom prst="ellipse">
+            <a:avLst/>
+          </a:prstGeom>
+          <a:solidFill>
+            <a:schemeClr val="accent4"/>
+          </a:solidFill>
+          <a:ln w="12700">
+            <a:solidFill>
+              <a:schemeClr val="accent4"/>
+            </a:solidFill>
+            <a:prstDash val="solid"/>
+          </a:ln>
+        </p:spPr>
+      </p:sp>
+      <p:sp>
+        <p:nvSpPr>
+          <p:cNvPr id="17" name="Text 15"/>
+          <p:cNvSpPr txBox="1"/>
+          <p:nvPr/>
+        </p:nvSpPr>
+        <p:spPr>
+          <a:xfrm>
+            <a:off x="6400800" y="3337560"/>
+            <a:ext cx="411480" cy="411480"/>
+          </a:xfrm>
+          <a:prstGeom prst="rect">
+            <a:avLst/>
+          </a:prstGeom>
+          <a:noFill/>
+          <a:ln/>
+        </p:spPr>
+        <p:txBody>
+          <a:bodyPr wrap="square" lIns="0" tIns="0" rIns="0" bIns="0" rtlCol="0" anchor="ctr"/>
+          <a:lstStyle/>
+          <a:p>
+            <a:pPr algn="ctr" indent="0" marL="0">
+              <a:buNone/>
+            </a:pPr>
+            <a:r>
+              <a:rPr lang="en-US" sz="1600" b="1" dirty="0">
+                <a:solidFill>
+                  <a:schemeClr val="bg1"/>
+                </a:solidFill>
+              </a:rPr>
+              <a:t>✓</a:t>
+            </a:r>
+            <a:endParaRPr lang="en-US" sz="1600" dirty="0"/>
+          </a:p>
+        </p:txBody>
+      </p:sp>
+      <p:sp>
+        <p:nvSpPr>
+          <p:cNvPr id="18" name="Text 16"/>
+          <p:cNvSpPr txBox="1"/>
+          <p:nvPr/>
+        </p:nvSpPr>
+        <p:spPr>
+          <a:xfrm>
+            <a:off x="6995160" y="3246120"/>
+            <a:ext cx="4434840" cy="1097280"/>
+          </a:xfrm>
+          <a:prstGeom prst="rect">
+            <a:avLst/>
+          </a:prstGeom>
+          <a:noFill/>
+          <a:ln/>
+        </p:spPr>
+        <p:txBody>
+          <a:bodyPr wrap="square" lIns="0" tIns="0" rIns="0" bIns="0" rtlCol="0" anchor="t"/>
+          <a:lstStyle/>
+          <a:p>
+            <a:pPr indent="0" marL="0">
+              <a:buNone/>
+            </a:pPr>
+            <a:r>
+              <a:rPr lang="en-US" sz="1400" b="1" dirty="0">
+                <a:solidFill>
+                  <a:schemeClr val="tx1"/>
+                </a:solidFill>
+              </a:rPr>
+              <a:t>No identity features</a:t>
+            </a:r>
+            <a:endParaRPr lang="en-US" sz="1400" dirty="0"/>
+          </a:p>
+          <a:p>
+            <a:pPr indent="0" marL="0">
+              <a:buNone/>
+            </a:pPr>
+            <a:r>
+              <a:rPr lang="en-US" sz="1400" dirty="0">
+                <a:solidFill>
+                  <a:srgbClr val="525252"/>
+                </a:solidFill>
+              </a:rPr>
+              <a:t>No age, nationality or ethnicity in the model; currency features flagged for a fairness check before real use</a:t>
+            </a:r>
+            <a:endParaRPr lang="en-US" sz="1400" dirty="0"/>
+          </a:p>
+        </p:txBody>
+      </p:sp>
+      <p:sp>
+        <p:nvSpPr>
+          <p:cNvPr id="19" name="ethics 5"/>
+          <p:cNvSpPr/>
+          <p:nvPr/>
+        </p:nvSpPr>
+        <p:spPr>
+          <a:xfrm>
+            <a:off x="548640" y="4663440"/>
+            <a:ext cx="5440680" cy="1417320"/>
+          </a:xfrm>
+          <a:prstGeom prst="roundRect">
+            <a:avLst>
+              <a:gd name="adj" fmla="val 7742"/>
+            </a:avLst>
+          </a:prstGeom>
+          <a:solidFill>
+            <a:srgbClr val="F2F4F8"/>
+          </a:solidFill>
+          <a:ln w="12700">
+            <a:solidFill>
+              <a:srgbClr val="F2F4F8"/>
+            </a:solidFill>
+            <a:prstDash val="solid"/>
+          </a:ln>
+        </p:spPr>
+      </p:sp>
+      <p:sp>
+        <p:nvSpPr>
+          <p:cNvPr id="20" name="tick 5"/>
+          <p:cNvSpPr/>
+          <p:nvPr/>
+        </p:nvSpPr>
+        <p:spPr>
+          <a:xfrm>
+            <a:off x="777240" y="4937760"/>
+            <a:ext cx="411480" cy="411480"/>
+          </a:xfrm>
+          <a:prstGeom prst="ellipse">
+            <a:avLst/>
+          </a:prstGeom>
+          <a:solidFill>
+            <a:schemeClr val="accent4"/>
+          </a:solidFill>
+          <a:ln w="12700">
+            <a:solidFill>
+              <a:schemeClr val="accent4"/>
+            </a:solidFill>
+            <a:prstDash val="solid"/>
+          </a:ln>
+        </p:spPr>
+      </p:sp>
+      <p:sp>
+        <p:nvSpPr>
+          <p:cNvPr id="21" name="Text 19"/>
+          <p:cNvSpPr txBox="1"/>
+          <p:nvPr/>
+        </p:nvSpPr>
+        <p:spPr>
+          <a:xfrm>
+            <a:off x="777240" y="4937760"/>
+            <a:ext cx="411480" cy="411480"/>
+          </a:xfrm>
+          <a:prstGeom prst="rect">
+            <a:avLst/>
+          </a:prstGeom>
+          <a:noFill/>
+          <a:ln/>
+        </p:spPr>
+        <p:txBody>
+          <a:bodyPr wrap="square" lIns="0" tIns="0" rIns="0" bIns="0" rtlCol="0" anchor="ctr"/>
+          <a:lstStyle/>
+          <a:p>
+            <a:pPr algn="ctr" indent="0" marL="0">
+              <a:buNone/>
+            </a:pPr>
+            <a:r>
+              <a:rPr lang="en-US" sz="1600" b="1" dirty="0">
+                <a:solidFill>
+                  <a:schemeClr val="bg1"/>
+                </a:solidFill>
+              </a:rPr>
+              <a:t>✓</a:t>
+            </a:r>
+            <a:endParaRPr lang="en-US" sz="1600" dirty="0"/>
+          </a:p>
+        </p:txBody>
+      </p:sp>
+      <p:sp>
+        <p:nvSpPr>
+          <p:cNvPr id="22" name="Text 20"/>
+          <p:cNvSpPr txBox="1"/>
+          <p:nvPr/>
+        </p:nvSpPr>
+        <p:spPr>
+          <a:xfrm>
+            <a:off x="1371600" y="4846320"/>
+            <a:ext cx="4434840" cy="1097280"/>
+          </a:xfrm>
+          <a:prstGeom prst="rect">
+            <a:avLst/>
+          </a:prstGeom>
+          <a:noFill/>
+          <a:ln/>
+        </p:spPr>
+        <p:txBody>
+          <a:bodyPr wrap="square" lIns="0" tIns="0" rIns="0" bIns="0" rtlCol="0" anchor="t"/>
+          <a:lstStyle/>
+          <a:p>
+            <a:pPr indent="0" marL="0">
+              <a:buNone/>
+            </a:pPr>
+            <a:r>
+              <a:rPr lang="en-US" sz="1400" b="1" dirty="0">
+                <a:solidFill>
+                  <a:schemeClr val="tx1"/>
+                </a:solidFill>
+              </a:rPr>
+              <a:t>Honest evaluation</a:t>
+            </a:r>
+            <a:endParaRPr lang="en-US" sz="1400" dirty="0"/>
+          </a:p>
+          <a:p>
+            <a:pPr indent="0" marL="0">
+              <a:buNone/>
+            </a:pPr>
+            <a:r>
+              <a:rPr lang="en-US" sz="1400" dirty="0">
+                <a:solidFill>
+                  <a:srgbClr val="525252"/>
+                </a:solidFill>
+              </a:rPr>
+              <a:t>Synthetic data labelled as such; test set used once; the failed Isolation Forest result reported</a:t>
+            </a:r>
+            <a:endParaRPr lang="en-US" sz="1400" dirty="0"/>
+          </a:p>
+        </p:txBody>
+      </p:sp>
+      <p:sp>
+        <p:nvSpPr>
+          <p:cNvPr id="23" name="ethics 6"/>
+          <p:cNvSpPr/>
+          <p:nvPr/>
+        </p:nvSpPr>
+        <p:spPr>
+          <a:xfrm>
+            <a:off x="6172200" y="4663440"/>
+            <a:ext cx="5440680" cy="1417320"/>
+          </a:xfrm>
+          <a:prstGeom prst="roundRect">
+            <a:avLst>
+              <a:gd name="adj" fmla="val 7742"/>
+            </a:avLst>
+          </a:prstGeom>
+          <a:solidFill>
+            <a:srgbClr val="F2F4F8"/>
+          </a:solidFill>
+          <a:ln w="12700">
+            <a:solidFill>
+              <a:srgbClr val="F2F4F8"/>
+            </a:solidFill>
+            <a:prstDash val="solid"/>
+          </a:ln>
+        </p:spPr>
+      </p:sp>
+      <p:sp>
+        <p:nvSpPr>
+          <p:cNvPr id="24" name="tick 6"/>
+          <p:cNvSpPr/>
+          <p:nvPr/>
+        </p:nvSpPr>
+        <p:spPr>
+          <a:xfrm>
+            <a:off x="6400800" y="4937760"/>
+            <a:ext cx="411480" cy="411480"/>
+          </a:xfrm>
+          <a:prstGeom prst="ellipse">
+            <a:avLst/>
+          </a:prstGeom>
+          <a:solidFill>
+            <a:schemeClr val="accent4"/>
+          </a:solidFill>
+          <a:ln w="12700">
+            <a:solidFill>
+              <a:schemeClr val="accent4"/>
+            </a:solidFill>
+            <a:prstDash val="solid"/>
+          </a:ln>
+        </p:spPr>
+      </p:sp>
+      <p:sp>
+        <p:nvSpPr>
+          <p:cNvPr id="25" name="Text 23"/>
+          <p:cNvSpPr txBox="1"/>
+          <p:nvPr/>
+        </p:nvSpPr>
+        <p:spPr>
+          <a:xfrm>
+            <a:off x="6400800" y="4937760"/>
+            <a:ext cx="411480" cy="411480"/>
+          </a:xfrm>
+          <a:prstGeom prst="rect">
+            <a:avLst/>
+          </a:prstGeom>
+          <a:noFill/>
+          <a:ln/>
+        </p:spPr>
+        <p:txBody>
+          <a:bodyPr wrap="square" lIns="0" tIns="0" rIns="0" bIns="0" rtlCol="0" anchor="ctr"/>
+          <a:lstStyle/>
+          <a:p>
+            <a:pPr algn="ctr" indent="0" marL="0">
+              <a:buNone/>
+            </a:pPr>
+            <a:r>
+              <a:rPr lang="en-US" sz="1600" b="1" dirty="0">
+                <a:solidFill>
+                  <a:schemeClr val="bg1"/>
+                </a:solidFill>
+              </a:rPr>
+              <a:t>✓</a:t>
+            </a:r>
+            <a:endParaRPr lang="en-US" sz="1600" dirty="0"/>
+          </a:p>
+        </p:txBody>
+      </p:sp>
+      <p:sp>
+        <p:nvSpPr>
+          <p:cNvPr id="26" name="Text 24"/>
+          <p:cNvSpPr txBox="1"/>
+          <p:nvPr/>
+        </p:nvSpPr>
+        <p:spPr>
+          <a:xfrm>
+            <a:off x="6995160" y="4846320"/>
+            <a:ext cx="4434840" cy="1097280"/>
+          </a:xfrm>
+          <a:prstGeom prst="rect">
+            <a:avLst/>
+          </a:prstGeom>
+          <a:noFill/>
+          <a:ln/>
+        </p:spPr>
+        <p:txBody>
+          <a:bodyPr wrap="square" lIns="0" tIns="0" rIns="0" bIns="0" rtlCol="0" anchor="t"/>
+          <a:lstStyle/>
+          <a:p>
+            <a:pPr indent="0" marL="0">
+              <a:buNone/>
+            </a:pPr>
+            <a:r>
+              <a:rPr lang="en-US" sz="1400" b="1" dirty="0">
+                <a:solidFill>
+                  <a:schemeClr val="tx1"/>
+                </a:solidFill>
+              </a:rPr>
+              <a:t>Privacy</a:t>
+            </a:r>
+            <a:endParaRPr lang="en-US" sz="1400" dirty="0"/>
+          </a:p>
+          <a:p>
+            <a:pPr indent="0" marL="0">
+              <a:buNone/>
+            </a:pPr>
+            <a:r>
+              <a:rPr lang="en-US" sz="1400" dirty="0">
+                <a:solidFill>
+                  <a:srgbClr val="525252"/>
+                </a:solidFill>
+              </a:rPr>
+              <a:t>Synthetic data, no real customers; scoring stays on the platform, nothing sent to outside services</a:t>
+            </a:r>
+            <a:endParaRPr lang="en-US" sz="1400" dirty="0"/>
+          </a:p>
+        </p:txBody>
+      </p:sp>
+      <p:sp>
+        <p:nvSpPr>
+          <p:cNvPr id="25" name="Slide Number Placeholder 0"/>
+          <p:cNvSpPr>
+            <a:spLocks noGrp="1"/>
+          </p:cNvSpPr>
+          <p:nvPr>
+            <p:ph type="sldNum" sz="quarter" idx="4294967295"/>
+          </p:nvPr>
+        </p:nvSpPr>
+        <p:spPr>
+          <a:xfrm>
+            <a:off x="11247120" y="6400800"/>
+            <a:ext cx="457200" cy="274320"/>
+          </a:xfrm>
+          <a:prstGeom prst="rect">
+            <a:avLst/>
+          </a:prstGeom>
+          <a:extLst>
+            <a:ext uri="{C572A759-6A51-4108-AA02-DFA0A04FC94B}">
+              <ma14:wrappingTextBoxFlag xmlns:ma14="http://schemas.microsoft.com/office/mac/drawingml/2011/main" val="0"/>
+            </a:ext>
+          </a:extLst>
+        </p:spPr>
+        <p:txBody>
+          <a:bodyPr/>
+          <a:lstStyle>
+            <a:lvl1pPr>
+              <a:defRPr sz="1000">
+                <a:solidFill>
+                  <a:srgbClr val="6F6F6F"/>
+                </a:solidFill>
+              </a:defRPr>
+            </a:lvl1pPr>
+          </a:lstStyle>
+          <a:p>
+            <a:pPr algn="r"/>
+            <a:fld id="{F7021451-1387-4CA6-816F-3879F97B5CBC}" type="slidenum">
+              <a:rPr b="0" lang="en-US"/>
+              <a:t>12</a:t>
+            </a:fld>
+            <a:endParaRPr lang="en-US"/>
+          </a:p>
+        </p:txBody>
+      </p:sp>
+    </p:spTree>
+  </p:cSld>
+  <p:clrMapOvr>
+    <a:masterClrMapping/>
+  </p:clrMapOvr>
+</p:sld>
+</file>
+
+<file path=ppt/slides/slide13.xml><?xml version="1.0" encoding="utf-8"?>
+<p:sld xmlns:a="http://schemas.openxmlformats.org/drawingml/2006/main" xmlns:r="http://schemas.openxmlformats.org/officeDocument/2006/relationships" xmlns:p="http://schemas.openxmlformats.org/presentationml/2006/main">
+  <p:cSld name="Slide 13">
+    <p:spTree>
+      <p:nvGrpSpPr>
+        <p:cNvPr id="1" name=""/>
+        <p:cNvGrpSpPr/>
+        <p:nvPr/>
+      </p:nvGrpSpPr>
+      <p:grpSpPr>
+        <a:xfrm>
+          <a:off x="0" y="0"/>
+          <a:ext cx="0" cy="0"/>
+          <a:chOff x="0" y="0"/>
+          <a:chExt cx="0" cy="0"/>
+        </a:xfrm>
+      </p:grpSpPr>
+      <p:sp>
+        <p:nvSpPr>
+          <p:cNvPr id="2" name="Text 0"/>
+          <p:cNvSpPr/>
+          <p:nvPr>
+            <p:ph idx="100" type="title" hasCustomPrompt="1"/>
+          </p:nvPr>
+        </p:nvSpPr>
+        <p:spPr>
+          <a:xfrm>
             <a:off x="731520" y="2103120"/>
             <a:ext cx="10698480" cy="1280160"/>
           </a:xfrm>
@@ -8055,592 +9271,36 @@
                   <a:schemeClr val="tx1"/>
                 </a:solidFill>
               </a:rPr>
-              <a:t>Built and running end to end on IBM LinuxONE (s390x)</a:t>
+              <a:t>The demo running live on LinuxONE</a:t>
             </a:r>
             <a:endParaRPr lang="en-US" sz="3200" dirty="0"/>
           </a:p>
         </p:txBody>
       </p:sp>
-      <p:sp>
-        <p:nvSpPr>
-          <p:cNvPr id="3" name="vm box"/>
-          <p:cNvSpPr/>
-          <p:nvPr/>
-        </p:nvSpPr>
-        <p:spPr>
-          <a:xfrm>
-            <a:off x="548640" y="1371600"/>
-            <a:ext cx="6949440" cy="4754880"/>
-          </a:xfrm>
-          <a:prstGeom prst="roundRect">
-            <a:avLst>
-              <a:gd name="adj" fmla="val 2308"/>
-            </a:avLst>
-          </a:prstGeom>
-          <a:solidFill>
-            <a:srgbClr val="F2F4F8"/>
-          </a:solidFill>
-          <a:ln w="12700">
-            <a:solidFill>
-              <a:srgbClr val="8D8D8D"/>
-            </a:solidFill>
-            <a:prstDash val="dash"/>
-          </a:ln>
-        </p:spPr>
-      </p:sp>
-      <p:sp>
-        <p:nvSpPr>
-          <p:cNvPr id="4" name="Text 2"/>
-          <p:cNvSpPr txBox="1"/>
-          <p:nvPr/>
-        </p:nvSpPr>
-        <p:spPr>
-          <a:xfrm>
-            <a:off x="822960" y="1463040"/>
-            <a:ext cx="6492240" cy="365760"/>
-          </a:xfrm>
-          <a:prstGeom prst="rect">
-            <a:avLst/>
-          </a:prstGeom>
-          <a:noFill/>
-          <a:ln/>
-        </p:spPr>
-        <p:txBody>
-          <a:bodyPr wrap="square" lIns="0" tIns="0" rIns="0" bIns="0" rtlCol="0" anchor="ctr"/>
-          <a:lstStyle/>
-          <a:p>
-            <a:pPr indent="0" marL="0">
-              <a:buNone/>
-            </a:pPr>
-            <a:r>
-              <a:rPr lang="en-US" sz="1300" b="1" dirty="0">
-                <a:solidFill>
-                  <a:srgbClr val="525252"/>
-                </a:solidFill>
-              </a:rPr>
-              <a:t>LinuxONE Community Cloud VM · s390x · 3 vCPU, 8 GB, no GPU</a:t>
-            </a:r>
-            <a:endParaRPr lang="en-US" sz="1300" dirty="0"/>
-          </a:p>
-        </p:txBody>
-      </p:sp>
-      <p:sp>
-        <p:nvSpPr>
-          <p:cNvPr id="5" name="jupyter"/>
-          <p:cNvSpPr/>
-          <p:nvPr/>
-        </p:nvSpPr>
-        <p:spPr>
-          <a:xfrm>
-            <a:off x="822960" y="1965960"/>
-            <a:ext cx="3017520" cy="1371600"/>
-          </a:xfrm>
-          <a:prstGeom prst="roundRect">
-            <a:avLst>
-              <a:gd name="adj" fmla="val 8000"/>
-            </a:avLst>
-          </a:prstGeom>
-          <a:solidFill>
-            <a:srgbClr val="FFFFFF"/>
-          </a:solidFill>
-          <a:ln w="12700">
-            <a:solidFill>
-              <a:srgbClr val="FFFFFF"/>
-            </a:solidFill>
-            <a:prstDash val="solid"/>
-          </a:ln>
-        </p:spPr>
-      </p:sp>
-      <p:sp>
-        <p:nvSpPr>
-          <p:cNvPr id="6" name="Text 4"/>
-          <p:cNvSpPr txBox="1"/>
-          <p:nvPr/>
-        </p:nvSpPr>
-        <p:spPr>
-          <a:xfrm>
-            <a:off x="1005840" y="2057400"/>
-            <a:ext cx="2651760" cy="1188720"/>
-          </a:xfrm>
-          <a:prstGeom prst="rect">
-            <a:avLst/>
-          </a:prstGeom>
-          <a:noFill/>
-          <a:ln/>
-        </p:spPr>
-        <p:txBody>
-          <a:bodyPr wrap="square" lIns="0" tIns="0" rIns="0" bIns="0" rtlCol="0" anchor="t"/>
-          <a:lstStyle/>
-          <a:p>
-            <a:pPr indent="0" marL="0">
-              <a:buNone/>
-            </a:pPr>
-            <a:r>
-              <a:rPr lang="en-US" sz="1600" b="1" dirty="0">
-                <a:solidFill>
-                  <a:srgbClr val="161616"/>
-                </a:solidFill>
-              </a:rPr>
-              <a:t>Jupyter container</a:t>
-            </a:r>
-            <a:endParaRPr lang="en-US" sz="1600" dirty="0"/>
-          </a:p>
-          <a:p>
-            <a:pPr indent="0" marL="0">
-              <a:buNone/>
-            </a:pPr>
-            <a:r>
-              <a:rPr lang="en-US" sz="1200" dirty="0">
-                <a:solidFill>
-                  <a:srgbClr val="161616"/>
-                </a:solidFill>
-              </a:rPr>
-              <a:t>Notebooks 01–03: cleaning, 25 features, XGBoost trained in 19.0 s</a:t>
-            </a:r>
-            <a:endParaRPr lang="en-US" sz="1600" dirty="0"/>
-          </a:p>
-        </p:txBody>
-      </p:sp>
-      <p:sp>
-        <p:nvSpPr>
-          <p:cNvPr id="7" name="mule-service"/>
-          <p:cNvSpPr/>
-          <p:nvPr/>
-        </p:nvSpPr>
-        <p:spPr>
-          <a:xfrm>
-            <a:off x="822960" y="4114800"/>
-            <a:ext cx="3017520" cy="1737360"/>
-          </a:xfrm>
-          <a:prstGeom prst="roundRect">
-            <a:avLst>
-              <a:gd name="adj" fmla="val 6316"/>
-            </a:avLst>
-          </a:prstGeom>
-          <a:solidFill>
-            <a:srgbClr val="0F62FE"/>
-          </a:solidFill>
-          <a:ln w="12700">
-            <a:solidFill>
-              <a:srgbClr val="0F62FE"/>
-            </a:solidFill>
-            <a:prstDash val="solid"/>
-          </a:ln>
-        </p:spPr>
-      </p:sp>
-      <p:sp>
-        <p:nvSpPr>
-          <p:cNvPr id="8" name="Text 6"/>
-          <p:cNvSpPr txBox="1"/>
-          <p:nvPr/>
-        </p:nvSpPr>
-        <p:spPr>
-          <a:xfrm>
-            <a:off x="1005840" y="4206240"/>
-            <a:ext cx="2651760" cy="1554480"/>
-          </a:xfrm>
-          <a:prstGeom prst="rect">
-            <a:avLst/>
-          </a:prstGeom>
-          <a:noFill/>
-          <a:ln/>
-        </p:spPr>
-        <p:txBody>
-          <a:bodyPr wrap="square" lIns="0" tIns="0" rIns="0" bIns="0" rtlCol="0" anchor="t"/>
-          <a:lstStyle/>
-          <a:p>
-            <a:pPr indent="0" marL="0">
-              <a:buNone/>
-            </a:pPr>
-            <a:r>
-              <a:rPr lang="en-US" sz="1600" b="1" dirty="0">
-                <a:solidFill>
-                  <a:srgbClr val="FFFFFF"/>
-                </a:solidFill>
-              </a:rPr>
-              <a:t>mule-service</a:t>
-            </a:r>
-            <a:endParaRPr lang="en-US" sz="1600" dirty="0"/>
-          </a:p>
-          <a:p>
-            <a:pPr indent="0" marL="0">
-              <a:buNone/>
-            </a:pPr>
-            <a:r>
-              <a:rPr lang="en-US" sz="1200" dirty="0">
-                <a:solidFill>
-                  <a:srgbClr val="FFFFFF"/>
-                </a:solidFill>
-              </a:rPr>
-              <a:t>Flask + XGBoost scoring API. Private network only, no public port</a:t>
-            </a:r>
-            <a:endParaRPr lang="en-US" sz="1600" dirty="0"/>
-          </a:p>
-        </p:txBody>
-      </p:sp>
-      <p:sp>
-        <p:nvSpPr>
-          <p:cNvPr id="9" name="studentshield"/>
-          <p:cNvSpPr/>
-          <p:nvPr/>
-        </p:nvSpPr>
-        <p:spPr>
-          <a:xfrm>
-            <a:off x="4251960" y="4114800"/>
-            <a:ext cx="3017520" cy="1737360"/>
-          </a:xfrm>
-          <a:prstGeom prst="roundRect">
-            <a:avLst>
-              <a:gd name="adj" fmla="val 6316"/>
-            </a:avLst>
-          </a:prstGeom>
-          <a:solidFill>
-            <a:srgbClr val="0F2B5B"/>
-          </a:solidFill>
-          <a:ln w="12700">
-            <a:solidFill>
-              <a:srgbClr val="0F2B5B"/>
-            </a:solidFill>
-            <a:prstDash val="solid"/>
-          </a:ln>
-        </p:spPr>
-      </p:sp>
-      <p:sp>
-        <p:nvSpPr>
-          <p:cNvPr id="10" name="Text 8"/>
-          <p:cNvSpPr txBox="1"/>
-          <p:nvPr/>
-        </p:nvSpPr>
-        <p:spPr>
-          <a:xfrm>
-            <a:off x="4434840" y="4206240"/>
-            <a:ext cx="2651760" cy="1554480"/>
-          </a:xfrm>
-          <a:prstGeom prst="rect">
-            <a:avLst/>
-          </a:prstGeom>
-          <a:noFill/>
-          <a:ln/>
-        </p:spPr>
-        <p:txBody>
-          <a:bodyPr wrap="square" lIns="0" tIns="0" rIns="0" bIns="0" rtlCol="0" anchor="t"/>
-          <a:lstStyle/>
-          <a:p>
-            <a:pPr indent="0" marL="0">
-              <a:buNone/>
-            </a:pPr>
-            <a:r>
-              <a:rPr lang="en-US" sz="1600" b="1" dirty="0">
-                <a:solidFill>
-                  <a:srgbClr val="FFFFFF"/>
-                </a:solidFill>
-              </a:rPr>
-              <a:t>studentshield</a:t>
-            </a:r>
-            <a:endParaRPr lang="en-US" sz="1600" dirty="0"/>
-          </a:p>
-          <a:p>
-            <a:pPr indent="0" marL="0">
-              <a:buNone/>
-            </a:pPr>
-            <a:r>
-              <a:rPr lang="en-US" sz="1200" dirty="0">
-                <a:solidFill>
-                  <a:srgbClr val="FFFFFF"/>
-                </a:solidFill>
-              </a:rPr>
-              <a:t>Flask web app, the only public port (5000)</a:t>
-            </a:r>
-            <a:endParaRPr lang="en-US" sz="1600" dirty="0"/>
-          </a:p>
-        </p:txBody>
-      </p:sp>
-      <p:sp>
-        <p:nvSpPr>
-          <p:cNvPr id="11" name="Text 9"/>
-          <p:cNvSpPr txBox="1"/>
-          <p:nvPr/>
-        </p:nvSpPr>
-        <p:spPr>
-          <a:xfrm>
-            <a:off x="822960" y="3520440"/>
-            <a:ext cx="3017520" cy="411480"/>
-          </a:xfrm>
-          <a:prstGeom prst="rect">
-            <a:avLst/>
-          </a:prstGeom>
-          <a:noFill/>
-          <a:ln/>
-        </p:spPr>
-        <p:txBody>
-          <a:bodyPr wrap="square" lIns="0" tIns="0" rIns="0" bIns="0" rtlCol="0" anchor="ctr"/>
-          <a:lstStyle/>
-          <a:p>
-            <a:pPr algn="ctr" indent="0" marL="0">
-              <a:buNone/>
-            </a:pPr>
-            <a:r>
-              <a:rPr lang="en-US" sz="1100" dirty="0">
-                <a:solidFill>
-                  <a:srgbClr val="525252"/>
-                </a:solidFill>
-              </a:rPr>
-              <a:t>model + cut-offs</a:t>
-            </a:r>
-            <a:endParaRPr lang="en-US" sz="1100" dirty="0"/>
-          </a:p>
-          <a:p>
-            <a:pPr algn="ctr" indent="0" marL="0">
-              <a:buNone/>
-            </a:pPr>
-            <a:r>
-              <a:rPr lang="en-US" sz="1100" dirty="0">
-                <a:solidFill>
-                  <a:srgbClr val="525252"/>
-                </a:solidFill>
-              </a:rPr>
-              <a:t>(shared folder) ↓</a:t>
-            </a:r>
-            <a:endParaRPr lang="en-US" sz="1100" dirty="0"/>
-          </a:p>
-        </p:txBody>
-      </p:sp>
-      <p:sp>
-        <p:nvSpPr>
-          <p:cNvPr id="12" name="Text 10"/>
-          <p:cNvSpPr txBox="1"/>
-          <p:nvPr/>
-        </p:nvSpPr>
-        <p:spPr>
-          <a:xfrm>
-            <a:off x="3840480" y="3749040"/>
-            <a:ext cx="914400" cy="320040"/>
-          </a:xfrm>
-          <a:prstGeom prst="rect">
-            <a:avLst/>
-          </a:prstGeom>
-          <a:noFill/>
-          <a:ln/>
-        </p:spPr>
-        <p:txBody>
-          <a:bodyPr wrap="square" lIns="0" tIns="0" rIns="0" bIns="0" rtlCol="0" anchor="ctr"/>
-          <a:lstStyle/>
-          <a:p>
-            <a:pPr algn="ctr" indent="0" marL="0">
-              <a:buNone/>
-            </a:pPr>
-            <a:r>
-              <a:rPr lang="en-US" sz="1000" dirty="0">
-                <a:solidFill>
-                  <a:srgbClr val="525252"/>
-                </a:solidFill>
-              </a:rPr>
-              <a:t>mule-net ↔</a:t>
-            </a:r>
-            <a:endParaRPr lang="en-US" sz="1000" dirty="0"/>
-          </a:p>
-        </p:txBody>
-      </p:sp>
-      <p:sp>
-        <p:nvSpPr>
-          <p:cNvPr id="13" name="Text 11"/>
-          <p:cNvSpPr txBox="1"/>
-          <p:nvPr/>
-        </p:nvSpPr>
-        <p:spPr>
-          <a:xfrm>
-            <a:off x="7863840" y="1417320"/>
-            <a:ext cx="3749040" cy="1097280"/>
-          </a:xfrm>
-          <a:prstGeom prst="rect">
-            <a:avLst/>
-          </a:prstGeom>
-          <a:noFill/>
-          <a:ln/>
-        </p:spPr>
-        <p:txBody>
-          <a:bodyPr wrap="square" lIns="0" tIns="0" rIns="0" bIns="0" rtlCol="0" anchor="t"/>
-          <a:lstStyle/>
-          <a:p>
-            <a:pPr indent="0" marL="0">
-              <a:buNone/>
-            </a:pPr>
-            <a:r>
-              <a:rPr lang="en-US" sz="1400" b="1" dirty="0">
-                <a:solidFill>
-                  <a:srgbClr val="0F62FE"/>
-                </a:solidFill>
-              </a:rPr>
-              <a:t>On-platform AI</a:t>
-            </a:r>
-            <a:endParaRPr lang="en-US" sz="1400" dirty="0"/>
-          </a:p>
-          <a:p>
-            <a:pPr indent="0" marL="0">
-              <a:buNone/>
-            </a:pPr>
-            <a:r>
-              <a:rPr lang="en-US" sz="1400" dirty="0">
-                <a:solidFill>
-                  <a:srgbClr val="161616"/>
-                </a:solidFill>
-              </a:rPr>
-              <a:t>Training and scoring both run on s390x; payment data never leaves the platform it lives on</a:t>
-            </a:r>
-            <a:endParaRPr lang="en-US" sz="1400" dirty="0"/>
-          </a:p>
-        </p:txBody>
-      </p:sp>
-      <p:sp>
-        <p:nvSpPr>
-          <p:cNvPr id="14" name="Text 12"/>
-          <p:cNvSpPr txBox="1"/>
-          <p:nvPr/>
-        </p:nvSpPr>
-        <p:spPr>
-          <a:xfrm>
-            <a:off x="7863840" y="2606040"/>
-            <a:ext cx="3749040" cy="1097280"/>
-          </a:xfrm>
-          <a:prstGeom prst="rect">
-            <a:avLst/>
-          </a:prstGeom>
-          <a:noFill/>
-          <a:ln/>
-        </p:spPr>
-        <p:txBody>
-          <a:bodyPr wrap="square" lIns="0" tIns="0" rIns="0" bIns="0" rtlCol="0" anchor="t"/>
-          <a:lstStyle/>
-          <a:p>
-            <a:pPr indent="0" marL="0">
-              <a:buNone/>
-            </a:pPr>
-            <a:r>
-              <a:rPr lang="en-US" sz="1400" b="1" dirty="0">
-                <a:solidFill>
-                  <a:srgbClr val="0F62FE"/>
-                </a:solidFill>
-              </a:rPr>
-              <a:t>Containerised</a:t>
-            </a:r>
-            <a:endParaRPr lang="en-US" sz="1400" dirty="0"/>
-          </a:p>
-          <a:p>
-            <a:pPr indent="0" marL="0">
-              <a:buNone/>
-            </a:pPr>
-            <a:r>
-              <a:rPr lang="en-US" sz="1400" dirty="0">
-                <a:solidFill>
-                  <a:srgbClr val="161616"/>
-                </a:solidFill>
-              </a:rPr>
-              <a:t>Docker images on IBM's s390x base image, --restart unless-stopped: both came back on their own after a VM restart</a:t>
-            </a:r>
-            <a:endParaRPr lang="en-US" sz="1400" dirty="0"/>
-          </a:p>
-        </p:txBody>
-      </p:sp>
-      <p:sp>
-        <p:nvSpPr>
-          <p:cNvPr id="15" name="Text 13"/>
-          <p:cNvSpPr txBox="1"/>
-          <p:nvPr/>
-        </p:nvSpPr>
-        <p:spPr>
-          <a:xfrm>
-            <a:off x="7863840" y="3794760"/>
-            <a:ext cx="3749040" cy="1097280"/>
-          </a:xfrm>
-          <a:prstGeom prst="rect">
-            <a:avLst/>
-          </a:prstGeom>
-          <a:noFill/>
-          <a:ln/>
-        </p:spPr>
-        <p:txBody>
-          <a:bodyPr wrap="square" lIns="0" tIns="0" rIns="0" bIns="0" rtlCol="0" anchor="t"/>
-          <a:lstStyle/>
-          <a:p>
-            <a:pPr indent="0" marL="0">
-              <a:buNone/>
-            </a:pPr>
-            <a:r>
-              <a:rPr lang="en-US" sz="1400" b="1" dirty="0">
-                <a:solidFill>
-                  <a:srgbClr val="0F62FE"/>
-                </a:solidFill>
-              </a:rPr>
-              <a:t>Secure by design</a:t>
-            </a:r>
-            <a:endParaRPr lang="en-US" sz="1400" dirty="0"/>
-          </a:p>
-          <a:p>
-            <a:pPr indent="0" marL="0">
-              <a:buNone/>
-            </a:pPr>
-            <a:r>
-              <a:rPr lang="en-US" sz="1400" dirty="0">
-                <a:solidFill>
-                  <a:srgbClr val="161616"/>
-                </a:solidFill>
-              </a:rPr>
-              <a:t>The model API sits on a private Docker network; only the web app is exposed</a:t>
-            </a:r>
-            <a:endParaRPr lang="en-US" sz="1400" dirty="0"/>
-          </a:p>
-        </p:txBody>
-      </p:sp>
-      <p:sp>
-        <p:nvSpPr>
-          <p:cNvPr id="16" name="Text 14"/>
-          <p:cNvSpPr txBox="1"/>
-          <p:nvPr/>
-        </p:nvSpPr>
-        <p:spPr>
-          <a:xfrm>
-            <a:off x="7863840" y="4983480"/>
-            <a:ext cx="3749040" cy="1097280"/>
-          </a:xfrm>
-          <a:prstGeom prst="rect">
-            <a:avLst/>
-          </a:prstGeom>
-          <a:noFill/>
-          <a:ln/>
-        </p:spPr>
-        <p:txBody>
-          <a:bodyPr wrap="square" lIns="0" tIns="0" rIns="0" bIns="0" rtlCol="0" anchor="t"/>
-          <a:lstStyle/>
-          <a:p>
-            <a:pPr indent="0" marL="0">
-              <a:buNone/>
-            </a:pPr>
-            <a:r>
-              <a:rPr lang="en-US" sz="1400" b="1" dirty="0">
-                <a:solidFill>
-                  <a:srgbClr val="0F62FE"/>
-                </a:solidFill>
-              </a:rPr>
-              <a:t>Real-time</a:t>
-            </a:r>
-            <a:endParaRPr lang="en-US" sz="1400" dirty="0"/>
-          </a:p>
-          <a:p>
-            <a:pPr indent="0" marL="0">
-              <a:buNone/>
-            </a:pPr>
-            <a:r>
-              <a:rPr lang="en-US" sz="1400" dirty="0">
-                <a:solidFill>
-                  <a:srgbClr val="161616"/>
-                </a:solidFill>
-              </a:rPr>
-              <a:t>Under a millisecond per payment; stateless scoring scales out with more replicas</a:t>
-            </a:r>
-            <a:endParaRPr lang="en-US" sz="1400" dirty="0"/>
-          </a:p>
-        </p:txBody>
-      </p:sp>
+      <p:pic>
+        <p:nvPicPr>
+          <p:cNvPr id="3" name="demo screenshot" descr="/home/claude/shots/07_demo_held_19h.png">    </p:cNvPr>
+          <p:cNvPicPr>
+            <a:picLocks noChangeAspect="1"/>
+          </p:cNvPicPr>
+          <p:nvPr/>
+        </p:nvPicPr>
+        <p:blipFill>
+          <a:blip r:embed="rId1"/>
+          <a:stretch>
+            <a:fillRect/>
+          </a:stretch>
+        </p:blipFill>
+        <p:spPr>
+          <a:xfrm>
+            <a:off x="1554480" y="1188720"/>
+            <a:ext cx="9089136" cy="5120640"/>
+          </a:xfrm>
+          <a:prstGeom prst="rect">
+            <a:avLst/>
+          </a:prstGeom>
+        </p:spPr>
+      </p:pic>
       <p:sp>
         <p:nvSpPr>
           <p:cNvPr id="25" name="Slide Number Placeholder 0"/>

</xml_diff>

<commit_message>
Add VM docker ps screenshot (README, report, deck)
Co-Authored-By: Claude Opus 5.5 <noreply@anthropic.com>
Claude-Session: https://claude.ai/code/session_01NWuP97XuxRF3YUECK7sHWt
</commit_message>
<xml_diff>
--- a/docs/Manchester.Ai_IBM_Z_Datathon_2026_Project.pptx
+++ b/docs/Manchester.Ai_IBM_Z_Datathon_2026_Project.pptx
@@ -119,30 +119,30 @@
   <p:extLst>
     <p:ext uri="{521415D9-36F7-43E2-AB2F-B90AF26B5E84}">
       <p14:sectionLst xmlns:p14="http://schemas.microsoft.com/office/powerpoint/2010/main">
-        <p14:section name="Opening" id="{61c3cbfc-7af3-3508-2fc2-8b35ce6c3dc0}">
+        <p14:section name="Opening" id="{0dbb4b6e-290e-8497-d4b0-46408511c7e7}">
           <p14:sldIdLst>
             <p14:sldId id="256"/>
           </p14:sldIdLst>
         </p14:section>
-        <p14:section name="Problem" id="{61ee6f04-89ef-df24-40ef-443a47ea217a}">
+        <p14:section name="Problem" id="{31e244c8-1fca-6222-8369-ea49e27d052a}">
           <p14:sldIdLst>
             <p14:sldId id="257"/>
           </p14:sldIdLst>
         </p14:section>
-        <p14:section name="Data and model" id="{044602b8-68e6-7713-7d0e-1fccf9de81e0}">
+        <p14:section name="Data and model" id="{1d285d3d-00c0-048b-e027-209332566443}">
           <p14:sldIdLst>
             <p14:sldId id="258"/>
             <p14:sldId id="259"/>
             <p14:sldId id="260"/>
           </p14:sldIdLst>
         </p14:section>
-        <p14:section name="Results" id="{26ea2fa7-a914-cae3-2b7f-298def47b179}">
+        <p14:section name="Results" id="{bcb458c0-005e-5bf6-df2f-c98154769194}">
           <p14:sldIdLst>
             <p14:sldId id="261"/>
             <p14:sldId id="262"/>
           </p14:sldIdLst>
         </p14:section>
-        <p14:section name="Demo and platform" id="{9937c0df-ec42-be94-38de-fff37d4483e2}">
+        <p14:section name="Demo and platform" id="{9d10ff82-0c08-af0e-c310-d28b47c2ea1a}">
           <p14:sldIdLst>
             <p14:sldId id="263"/>
             <p14:sldId id="264"/>
@@ -150,7 +150,7 @@
             <p14:sldId id="266"/>
           </p14:sldIdLst>
         </p14:section>
-        <p14:section name="Close" id="{c3d1d42c-51d9-67c4-2499-d5b475a2bdb4}">
+        <p14:section name="Close" id="{a0f4a8d8-ee6c-68cb-b286-168a73d16e6d}">
           <p14:sldIdLst>
             <p14:sldId id="267"/>
             <p14:sldId id="268"/>
@@ -3811,6 +3811,66 @@
                 </a:solidFill>
               </a:rPr>
               <a:t>Notebook 03 on LinuxONE: XGBoost trained on s390x in 19.0 s</a:t>
+            </a:r>
+            <a:endParaRPr lang="en-US" sz="1100" dirty="0"/>
+          </a:p>
+        </p:txBody>
+      </p:sp>
+      <p:pic>
+        <p:nvPicPr>
+          <p:cNvPr id="11" name="docker ps" descr="/home/claude/shots/04_vm_docker_ps.png">    </p:cNvPr>
+          <p:cNvPicPr>
+            <a:picLocks noChangeAspect="1"/>
+          </p:cNvPicPr>
+          <p:nvPr/>
+        </p:nvPicPr>
+        <p:blipFill>
+          <a:blip r:embed="rId5"/>
+          <a:stretch>
+            <a:fillRect/>
+          </a:stretch>
+        </p:blipFill>
+        <p:spPr>
+          <a:xfrm>
+            <a:off x="6355080" y="4709160"/>
+            <a:ext cx="5257800" cy="525780"/>
+          </a:xfrm>
+          <a:prstGeom prst="rect">
+            <a:avLst/>
+          </a:prstGeom>
+        </p:spPr>
+      </p:pic>
+      <p:sp>
+        <p:nvSpPr>
+          <p:cNvPr id="12" name="Text 5"/>
+          <p:cNvSpPr txBox="1"/>
+          <p:nvPr/>
+        </p:nvSpPr>
+        <p:spPr>
+          <a:xfrm>
+            <a:off x="6355080" y="5303520"/>
+            <a:ext cx="5257800" cy="457200"/>
+          </a:xfrm>
+          <a:prstGeom prst="rect">
+            <a:avLst/>
+          </a:prstGeom>
+          <a:noFill/>
+          <a:ln/>
+        </p:spPr>
+        <p:txBody>
+          <a:bodyPr wrap="square" lIns="0" tIns="0" rIns="0" bIns="0" rtlCol="0" anchor="t"/>
+          <a:lstStyle/>
+          <a:p>
+            <a:pPr indent="0" marL="0">
+              <a:buNone/>
+            </a:pPr>
+            <a:r>
+              <a:rPr lang="en-US" sz="1100" dirty="0">
+                <a:solidFill>
+                  <a:srgbClr val="525252"/>
+                </a:solidFill>
+              </a:rPr>
+              <a:t>VM terminal: s390x; docker ps shows studentshield (public :5000), mule-service (private) and Jupyter</a:t>
             </a:r>
             <a:endParaRPr lang="en-US" sz="1100" dirty="0"/>
           </a:p>

</xml_diff>